<commit_message>
feat: compare models in results report
</commit_message>
<xml_diff>
--- a/data/model/decision-tree-results-review.pptx
+++ b/data/model/decision-tree-results-review.pptx
@@ -5,9 +5,9 @@
     <p:sldMasterId id="2147483648" r:id="rId1"/>
   </p:sldMasterIdLst>
   <p:sldIdLst>
-    <p:sldId id="256" r:id="rId2"/>
+    <p:sldId id="256" r:id="rId7"/>
   </p:sldIdLst>
-  <p:sldSz cx="12192000" cy="6858000"/>
+  <p:sldSz cx="12191999" cy="6858000" type="screen4x3"/>
   <p:notesSz cx="6858000" cy="9144000"/>
   <p:defaultTextStyle>
     <a:defPPr>
@@ -104,31 +104,7 @@
       </a:defRPr>
     </a:lvl9pPr>
   </p:defaultTextStyle>
-  <p:extLst>
-    <p:ext uri="{EFAFB233-063F-42B5-8137-9DF3F51BA10A}">
-      <p15:sldGuideLst xmlns:p15="http://schemas.microsoft.com/office/powerpoint/2012/main">
-        <p15:guide id="1" orient="horz" pos="2160">
-          <p15:clr>
-            <a:srgbClr val="A4A3A4"/>
-          </p15:clr>
-        </p15:guide>
-        <p15:guide id="2" pos="2880">
-          <p15:clr>
-            <a:srgbClr val="A4A3A4"/>
-          </p15:clr>
-        </p15:guide>
-      </p15:sldGuideLst>
-    </p:ext>
-  </p:extLst>
 </p:presentation>
-</file>
-
-<file path=ppt/revisionInfo.xml><?xml version="1.0" encoding="utf-8"?>
-<p1510:revInfo xmlns:a="http://schemas.openxmlformats.org/drawingml/2006/main" xmlns:r="http://schemas.openxmlformats.org/officeDocument/2006/relationships" xmlns:p1510="http://schemas.microsoft.com/office/powerpoint/2015/10/main">
-  <p1510:revLst>
-    <p1510:client id="{C5343C9B-C74F-4DAB-9924-2E09E855C159}" v="5" dt="2026-07-15T05:29:03.170"/>
-  </p1510:revLst>
-</p1510:revInfo>
 </file>
 
 <file path=ppt/slideLayouts/slideLayout1.xml><?xml version="1.0" encoding="utf-8"?>
@@ -169,9 +145,10 @@
           <a:lstStyle/>
           <a:p>
             <a:r>
-              <a:rPr lang="en-US"/>
+              <a:rPr lang="en-US" smtClean="0"/>
               <a:t>Click to edit Master title style</a:t>
             </a:r>
+            <a:endParaRPr lang="en-US"/>
           </a:p>
         </p:txBody>
       </p:sp>
@@ -287,9 +264,10 @@
           </a:lstStyle>
           <a:p>
             <a:r>
-              <a:rPr lang="en-US"/>
+              <a:rPr lang="en-US" smtClean="0"/>
               <a:t>Click to edit Master subtitle style</a:t>
             </a:r>
+            <a:endParaRPr lang="en-US"/>
           </a:p>
         </p:txBody>
       </p:sp>
@@ -310,7 +288,7 @@
           <a:p>
             <a:fld id="{5BCAD085-E8A6-8845-BD4E-CB4CCA059FC4}" type="datetimeFigureOut">
               <a:rPr lang="en-US" smtClean="0"/>
-              <a:t>7/14/2026</a:t>
+              <a:t>1/27/13</a:t>
             </a:fld>
             <a:endParaRPr lang="en-US"/>
           </a:p>
@@ -404,9 +382,10 @@
           <a:lstStyle/>
           <a:p>
             <a:r>
-              <a:rPr lang="en-US"/>
+              <a:rPr lang="en-US" smtClean="0"/>
               <a:t>Click to edit Master title style</a:t>
             </a:r>
+            <a:endParaRPr lang="en-US"/>
           </a:p>
         </p:txBody>
       </p:sp>
@@ -427,37 +406,38 @@
           <a:p>
             <a:pPr lvl="0"/>
             <a:r>
-              <a:rPr lang="en-US"/>
+              <a:rPr lang="en-US" smtClean="0"/>
               <a:t>Click to edit Master text styles</a:t>
             </a:r>
           </a:p>
           <a:p>
             <a:pPr lvl="1"/>
             <a:r>
-              <a:rPr lang="en-US"/>
+              <a:rPr lang="en-US" smtClean="0"/>
               <a:t>Second level</a:t>
             </a:r>
           </a:p>
           <a:p>
             <a:pPr lvl="2"/>
             <a:r>
-              <a:rPr lang="en-US"/>
+              <a:rPr lang="en-US" smtClean="0"/>
               <a:t>Third level</a:t>
             </a:r>
           </a:p>
           <a:p>
             <a:pPr lvl="3"/>
             <a:r>
-              <a:rPr lang="en-US"/>
+              <a:rPr lang="en-US" smtClean="0"/>
               <a:t>Fourth level</a:t>
             </a:r>
           </a:p>
           <a:p>
             <a:pPr lvl="4"/>
             <a:r>
-              <a:rPr lang="en-US"/>
+              <a:rPr lang="en-US" smtClean="0"/>
               <a:t>Fifth level</a:t>
             </a:r>
+            <a:endParaRPr lang="en-US"/>
           </a:p>
         </p:txBody>
       </p:sp>
@@ -478,7 +458,7 @@
           <a:p>
             <a:fld id="{5BCAD085-E8A6-8845-BD4E-CB4CCA059FC4}" type="datetimeFigureOut">
               <a:rPr lang="en-US" smtClean="0"/>
-              <a:t>7/14/2026</a:t>
+              <a:t>1/27/13</a:t>
             </a:fld>
             <a:endParaRPr lang="en-US"/>
           </a:p>
@@ -577,9 +557,10 @@
           <a:lstStyle/>
           <a:p>
             <a:r>
-              <a:rPr lang="en-US"/>
+              <a:rPr lang="en-US" smtClean="0"/>
               <a:t>Click to edit Master title style</a:t>
             </a:r>
+            <a:endParaRPr lang="en-US"/>
           </a:p>
         </p:txBody>
       </p:sp>
@@ -605,37 +586,38 @@
           <a:p>
             <a:pPr lvl="0"/>
             <a:r>
-              <a:rPr lang="en-US"/>
+              <a:rPr lang="en-US" smtClean="0"/>
               <a:t>Click to edit Master text styles</a:t>
             </a:r>
           </a:p>
           <a:p>
             <a:pPr lvl="1"/>
             <a:r>
-              <a:rPr lang="en-US"/>
+              <a:rPr lang="en-US" smtClean="0"/>
               <a:t>Second level</a:t>
             </a:r>
           </a:p>
           <a:p>
             <a:pPr lvl="2"/>
             <a:r>
-              <a:rPr lang="en-US"/>
+              <a:rPr lang="en-US" smtClean="0"/>
               <a:t>Third level</a:t>
             </a:r>
           </a:p>
           <a:p>
             <a:pPr lvl="3"/>
             <a:r>
-              <a:rPr lang="en-US"/>
+              <a:rPr lang="en-US" smtClean="0"/>
               <a:t>Fourth level</a:t>
             </a:r>
           </a:p>
           <a:p>
             <a:pPr lvl="4"/>
             <a:r>
-              <a:rPr lang="en-US"/>
+              <a:rPr lang="en-US" smtClean="0"/>
               <a:t>Fifth level</a:t>
             </a:r>
+            <a:endParaRPr lang="en-US"/>
           </a:p>
         </p:txBody>
       </p:sp>
@@ -656,7 +638,7 @@
           <a:p>
             <a:fld id="{5BCAD085-E8A6-8845-BD4E-CB4CCA059FC4}" type="datetimeFigureOut">
               <a:rPr lang="en-US" smtClean="0"/>
-              <a:t>7/14/2026</a:t>
+              <a:t>1/27/13</a:t>
             </a:fld>
             <a:endParaRPr lang="en-US"/>
           </a:p>
@@ -750,9 +732,10 @@
           <a:lstStyle/>
           <a:p>
             <a:r>
-              <a:rPr lang="en-US"/>
+              <a:rPr lang="en-US" smtClean="0"/>
               <a:t>Click to edit Master title style</a:t>
             </a:r>
+            <a:endParaRPr lang="en-US"/>
           </a:p>
         </p:txBody>
       </p:sp>
@@ -773,37 +756,38 @@
           <a:p>
             <a:pPr lvl="0"/>
             <a:r>
-              <a:rPr lang="en-US"/>
+              <a:rPr lang="en-US" smtClean="0"/>
               <a:t>Click to edit Master text styles</a:t>
             </a:r>
           </a:p>
           <a:p>
             <a:pPr lvl="1"/>
             <a:r>
-              <a:rPr lang="en-US"/>
+              <a:rPr lang="en-US" smtClean="0"/>
               <a:t>Second level</a:t>
             </a:r>
           </a:p>
           <a:p>
             <a:pPr lvl="2"/>
             <a:r>
-              <a:rPr lang="en-US"/>
+              <a:rPr lang="en-US" smtClean="0"/>
               <a:t>Third level</a:t>
             </a:r>
           </a:p>
           <a:p>
             <a:pPr lvl="3"/>
             <a:r>
-              <a:rPr lang="en-US"/>
+              <a:rPr lang="en-US" smtClean="0"/>
               <a:t>Fourth level</a:t>
             </a:r>
           </a:p>
           <a:p>
             <a:pPr lvl="4"/>
             <a:r>
-              <a:rPr lang="en-US"/>
+              <a:rPr lang="en-US" smtClean="0"/>
               <a:t>Fifth level</a:t>
             </a:r>
+            <a:endParaRPr lang="en-US"/>
           </a:p>
         </p:txBody>
       </p:sp>
@@ -824,7 +808,7 @@
           <a:p>
             <a:fld id="{5BCAD085-E8A6-8845-BD4E-CB4CCA059FC4}" type="datetimeFigureOut">
               <a:rPr lang="en-US" smtClean="0"/>
-              <a:t>7/14/2026</a:t>
+              <a:t>1/27/13</a:t>
             </a:fld>
             <a:endParaRPr lang="en-US"/>
           </a:p>
@@ -927,9 +911,10 @@
           </a:lstStyle>
           <a:p>
             <a:r>
-              <a:rPr lang="en-US"/>
+              <a:rPr lang="en-US" smtClean="0"/>
               <a:t>Click to edit Master title style</a:t>
             </a:r>
+            <a:endParaRPr lang="en-US"/>
           </a:p>
         </p:txBody>
       </p:sp>
@@ -1046,7 +1031,7 @@
           <a:p>
             <a:pPr lvl="0"/>
             <a:r>
-              <a:rPr lang="en-US"/>
+              <a:rPr lang="en-US" smtClean="0"/>
               <a:t>Click to edit Master text styles</a:t>
             </a:r>
           </a:p>
@@ -1069,7 +1054,7 @@
           <a:p>
             <a:fld id="{5BCAD085-E8A6-8845-BD4E-CB4CCA059FC4}" type="datetimeFigureOut">
               <a:rPr lang="en-US" smtClean="0"/>
-              <a:t>7/14/2026</a:t>
+              <a:t>1/27/13</a:t>
             </a:fld>
             <a:endParaRPr lang="en-US"/>
           </a:p>
@@ -1163,9 +1148,10 @@
           <a:lstStyle/>
           <a:p>
             <a:r>
-              <a:rPr lang="en-US"/>
+              <a:rPr lang="en-US" smtClean="0"/>
               <a:t>Click to edit Master title style</a:t>
             </a:r>
+            <a:endParaRPr lang="en-US"/>
           </a:p>
         </p:txBody>
       </p:sp>
@@ -1219,37 +1205,38 @@
           <a:p>
             <a:pPr lvl="0"/>
             <a:r>
-              <a:rPr lang="en-US"/>
+              <a:rPr lang="en-US" smtClean="0"/>
               <a:t>Click to edit Master text styles</a:t>
             </a:r>
           </a:p>
           <a:p>
             <a:pPr lvl="1"/>
             <a:r>
-              <a:rPr lang="en-US"/>
+              <a:rPr lang="en-US" smtClean="0"/>
               <a:t>Second level</a:t>
             </a:r>
           </a:p>
           <a:p>
             <a:pPr lvl="2"/>
             <a:r>
-              <a:rPr lang="en-US"/>
+              <a:rPr lang="en-US" smtClean="0"/>
               <a:t>Third level</a:t>
             </a:r>
           </a:p>
           <a:p>
             <a:pPr lvl="3"/>
             <a:r>
-              <a:rPr lang="en-US"/>
+              <a:rPr lang="en-US" smtClean="0"/>
               <a:t>Fourth level</a:t>
             </a:r>
           </a:p>
           <a:p>
             <a:pPr lvl="4"/>
             <a:r>
-              <a:rPr lang="en-US"/>
+              <a:rPr lang="en-US" smtClean="0"/>
               <a:t>Fifth level</a:t>
             </a:r>
+            <a:endParaRPr lang="en-US"/>
           </a:p>
         </p:txBody>
       </p:sp>
@@ -1303,37 +1290,38 @@
           <a:p>
             <a:pPr lvl="0"/>
             <a:r>
-              <a:rPr lang="en-US"/>
+              <a:rPr lang="en-US" smtClean="0"/>
               <a:t>Click to edit Master text styles</a:t>
             </a:r>
           </a:p>
           <a:p>
             <a:pPr lvl="1"/>
             <a:r>
-              <a:rPr lang="en-US"/>
+              <a:rPr lang="en-US" smtClean="0"/>
               <a:t>Second level</a:t>
             </a:r>
           </a:p>
           <a:p>
             <a:pPr lvl="2"/>
             <a:r>
-              <a:rPr lang="en-US"/>
+              <a:rPr lang="en-US" smtClean="0"/>
               <a:t>Third level</a:t>
             </a:r>
           </a:p>
           <a:p>
             <a:pPr lvl="3"/>
             <a:r>
-              <a:rPr lang="en-US"/>
+              <a:rPr lang="en-US" smtClean="0"/>
               <a:t>Fourth level</a:t>
             </a:r>
           </a:p>
           <a:p>
             <a:pPr lvl="4"/>
             <a:r>
-              <a:rPr lang="en-US"/>
+              <a:rPr lang="en-US" smtClean="0"/>
               <a:t>Fifth level</a:t>
             </a:r>
+            <a:endParaRPr lang="en-US"/>
           </a:p>
         </p:txBody>
       </p:sp>
@@ -1354,7 +1342,7 @@
           <a:p>
             <a:fld id="{5BCAD085-E8A6-8845-BD4E-CB4CCA059FC4}" type="datetimeFigureOut">
               <a:rPr lang="en-US" smtClean="0"/>
-              <a:t>7/14/2026</a:t>
+              <a:t>1/27/13</a:t>
             </a:fld>
             <a:endParaRPr lang="en-US"/>
           </a:p>
@@ -1452,9 +1440,10 @@
           </a:lstStyle>
           <a:p>
             <a:r>
-              <a:rPr lang="en-US"/>
+              <a:rPr lang="en-US" smtClean="0"/>
               <a:t>Click to edit Master title style</a:t>
             </a:r>
+            <a:endParaRPr lang="en-US"/>
           </a:p>
         </p:txBody>
       </p:sp>
@@ -1517,7 +1506,7 @@
           <a:p>
             <a:pPr lvl="0"/>
             <a:r>
-              <a:rPr lang="en-US"/>
+              <a:rPr lang="en-US" smtClean="0"/>
               <a:t>Click to edit Master text styles</a:t>
             </a:r>
           </a:p>
@@ -1573,37 +1562,38 @@
           <a:p>
             <a:pPr lvl="0"/>
             <a:r>
-              <a:rPr lang="en-US"/>
+              <a:rPr lang="en-US" smtClean="0"/>
               <a:t>Click to edit Master text styles</a:t>
             </a:r>
           </a:p>
           <a:p>
             <a:pPr lvl="1"/>
             <a:r>
-              <a:rPr lang="en-US"/>
+              <a:rPr lang="en-US" smtClean="0"/>
               <a:t>Second level</a:t>
             </a:r>
           </a:p>
           <a:p>
             <a:pPr lvl="2"/>
             <a:r>
-              <a:rPr lang="en-US"/>
+              <a:rPr lang="en-US" smtClean="0"/>
               <a:t>Third level</a:t>
             </a:r>
           </a:p>
           <a:p>
             <a:pPr lvl="3"/>
             <a:r>
-              <a:rPr lang="en-US"/>
+              <a:rPr lang="en-US" smtClean="0"/>
               <a:t>Fourth level</a:t>
             </a:r>
           </a:p>
           <a:p>
             <a:pPr lvl="4"/>
             <a:r>
-              <a:rPr lang="en-US"/>
+              <a:rPr lang="en-US" smtClean="0"/>
               <a:t>Fifth level</a:t>
             </a:r>
+            <a:endParaRPr lang="en-US"/>
           </a:p>
         </p:txBody>
       </p:sp>
@@ -1666,7 +1656,7 @@
           <a:p>
             <a:pPr lvl="0"/>
             <a:r>
-              <a:rPr lang="en-US"/>
+              <a:rPr lang="en-US" smtClean="0"/>
               <a:t>Click to edit Master text styles</a:t>
             </a:r>
           </a:p>
@@ -1722,37 +1712,38 @@
           <a:p>
             <a:pPr lvl="0"/>
             <a:r>
-              <a:rPr lang="en-US"/>
+              <a:rPr lang="en-US" smtClean="0"/>
               <a:t>Click to edit Master text styles</a:t>
             </a:r>
           </a:p>
           <a:p>
             <a:pPr lvl="1"/>
             <a:r>
-              <a:rPr lang="en-US"/>
+              <a:rPr lang="en-US" smtClean="0"/>
               <a:t>Second level</a:t>
             </a:r>
           </a:p>
           <a:p>
             <a:pPr lvl="2"/>
             <a:r>
-              <a:rPr lang="en-US"/>
+              <a:rPr lang="en-US" smtClean="0"/>
               <a:t>Third level</a:t>
             </a:r>
           </a:p>
           <a:p>
             <a:pPr lvl="3"/>
             <a:r>
-              <a:rPr lang="en-US"/>
+              <a:rPr lang="en-US" smtClean="0"/>
               <a:t>Fourth level</a:t>
             </a:r>
           </a:p>
           <a:p>
             <a:pPr lvl="4"/>
             <a:r>
-              <a:rPr lang="en-US"/>
+              <a:rPr lang="en-US" smtClean="0"/>
               <a:t>Fifth level</a:t>
             </a:r>
+            <a:endParaRPr lang="en-US"/>
           </a:p>
         </p:txBody>
       </p:sp>
@@ -1773,7 +1764,7 @@
           <a:p>
             <a:fld id="{5BCAD085-E8A6-8845-BD4E-CB4CCA059FC4}" type="datetimeFigureOut">
               <a:rPr lang="en-US" smtClean="0"/>
-              <a:t>7/14/2026</a:t>
+              <a:t>1/27/13</a:t>
             </a:fld>
             <a:endParaRPr lang="en-US"/>
           </a:p>
@@ -1867,9 +1858,10 @@
           <a:lstStyle/>
           <a:p>
             <a:r>
-              <a:rPr lang="en-US"/>
+              <a:rPr lang="en-US" smtClean="0"/>
               <a:t>Click to edit Master title style</a:t>
             </a:r>
+            <a:endParaRPr lang="en-US"/>
           </a:p>
         </p:txBody>
       </p:sp>
@@ -1890,7 +1882,7 @@
           <a:p>
             <a:fld id="{5BCAD085-E8A6-8845-BD4E-CB4CCA059FC4}" type="datetimeFigureOut">
               <a:rPr lang="en-US" smtClean="0"/>
-              <a:t>7/14/2026</a:t>
+              <a:t>1/27/13</a:t>
             </a:fld>
             <a:endParaRPr lang="en-US"/>
           </a:p>
@@ -1985,7 +1977,7 @@
           <a:p>
             <a:fld id="{5BCAD085-E8A6-8845-BD4E-CB4CCA059FC4}" type="datetimeFigureOut">
               <a:rPr lang="en-US" smtClean="0"/>
-              <a:t>7/14/2026</a:t>
+              <a:t>1/27/13</a:t>
             </a:fld>
             <a:endParaRPr lang="en-US"/>
           </a:p>
@@ -2088,9 +2080,10 @@
           </a:lstStyle>
           <a:p>
             <a:r>
-              <a:rPr lang="en-US"/>
+              <a:rPr lang="en-US" smtClean="0"/>
               <a:t>Click to edit Master title style</a:t>
             </a:r>
+            <a:endParaRPr lang="en-US"/>
           </a:p>
         </p:txBody>
       </p:sp>
@@ -2144,37 +2137,38 @@
           <a:p>
             <a:pPr lvl="0"/>
             <a:r>
-              <a:rPr lang="en-US"/>
+              <a:rPr lang="en-US" smtClean="0"/>
               <a:t>Click to edit Master text styles</a:t>
             </a:r>
           </a:p>
           <a:p>
             <a:pPr lvl="1"/>
             <a:r>
-              <a:rPr lang="en-US"/>
+              <a:rPr lang="en-US" smtClean="0"/>
               <a:t>Second level</a:t>
             </a:r>
           </a:p>
           <a:p>
             <a:pPr lvl="2"/>
             <a:r>
-              <a:rPr lang="en-US"/>
+              <a:rPr lang="en-US" smtClean="0"/>
               <a:t>Third level</a:t>
             </a:r>
           </a:p>
           <a:p>
             <a:pPr lvl="3"/>
             <a:r>
-              <a:rPr lang="en-US"/>
+              <a:rPr lang="en-US" smtClean="0"/>
               <a:t>Fourth level</a:t>
             </a:r>
           </a:p>
           <a:p>
             <a:pPr lvl="4"/>
             <a:r>
-              <a:rPr lang="en-US"/>
+              <a:rPr lang="en-US" smtClean="0"/>
               <a:t>Fifth level</a:t>
             </a:r>
+            <a:endParaRPr lang="en-US"/>
           </a:p>
         </p:txBody>
       </p:sp>
@@ -2237,7 +2231,7 @@
           <a:p>
             <a:pPr lvl="0"/>
             <a:r>
-              <a:rPr lang="en-US"/>
+              <a:rPr lang="en-US" smtClean="0"/>
               <a:t>Click to edit Master text styles</a:t>
             </a:r>
           </a:p>
@@ -2260,7 +2254,7 @@
           <a:p>
             <a:fld id="{5BCAD085-E8A6-8845-BD4E-CB4CCA059FC4}" type="datetimeFigureOut">
               <a:rPr lang="en-US" smtClean="0"/>
-              <a:t>7/14/2026</a:t>
+              <a:t>1/27/13</a:t>
             </a:fld>
             <a:endParaRPr lang="en-US"/>
           </a:p>
@@ -2363,9 +2357,10 @@
           </a:lstStyle>
           <a:p>
             <a:r>
-              <a:rPr lang="en-US"/>
+              <a:rPr lang="en-US" smtClean="0"/>
               <a:t>Click to edit Master title style</a:t>
             </a:r>
+            <a:endParaRPr lang="en-US"/>
           </a:p>
         </p:txBody>
       </p:sp>
@@ -2489,7 +2484,7 @@
           <a:p>
             <a:pPr lvl="0"/>
             <a:r>
-              <a:rPr lang="en-US"/>
+              <a:rPr lang="en-US" smtClean="0"/>
               <a:t>Click to edit Master text styles</a:t>
             </a:r>
           </a:p>
@@ -2512,7 +2507,7 @@
           <a:p>
             <a:fld id="{5BCAD085-E8A6-8845-BD4E-CB4CCA059FC4}" type="datetimeFigureOut">
               <a:rPr lang="en-US" smtClean="0"/>
-              <a:t>7/14/2026</a:t>
+              <a:t>1/27/13</a:t>
             </a:fld>
             <a:endParaRPr lang="en-US"/>
           </a:p>
@@ -2621,9 +2616,10 @@
           <a:lstStyle/>
           <a:p>
             <a:r>
-              <a:rPr lang="en-US"/>
+              <a:rPr lang="en-US" smtClean="0"/>
               <a:t>Click to edit Master title style</a:t>
             </a:r>
+            <a:endParaRPr lang="en-US"/>
           </a:p>
         </p:txBody>
       </p:sp>
@@ -2654,37 +2650,38 @@
           <a:p>
             <a:pPr lvl="0"/>
             <a:r>
-              <a:rPr lang="en-US"/>
+              <a:rPr lang="en-US" smtClean="0"/>
               <a:t>Click to edit Master text styles</a:t>
             </a:r>
           </a:p>
           <a:p>
             <a:pPr lvl="1"/>
             <a:r>
-              <a:rPr lang="en-US"/>
+              <a:rPr lang="en-US" smtClean="0"/>
               <a:t>Second level</a:t>
             </a:r>
           </a:p>
           <a:p>
             <a:pPr lvl="2"/>
             <a:r>
-              <a:rPr lang="en-US"/>
+              <a:rPr lang="en-US" smtClean="0"/>
               <a:t>Third level</a:t>
             </a:r>
           </a:p>
           <a:p>
             <a:pPr lvl="3"/>
             <a:r>
-              <a:rPr lang="en-US"/>
+              <a:rPr lang="en-US" smtClean="0"/>
               <a:t>Fourth level</a:t>
             </a:r>
           </a:p>
           <a:p>
             <a:pPr lvl="4"/>
             <a:r>
-              <a:rPr lang="en-US"/>
+              <a:rPr lang="en-US" smtClean="0"/>
               <a:t>Fifth level</a:t>
             </a:r>
+            <a:endParaRPr lang="en-US"/>
           </a:p>
         </p:txBody>
       </p:sp>
@@ -2723,7 +2720,7 @@
           <a:p>
             <a:fld id="{5BCAD085-E8A6-8845-BD4E-CB4CCA059FC4}" type="datetimeFigureOut">
               <a:rPr lang="en-US" smtClean="0"/>
-              <a:t>7/14/2026</a:t>
+              <a:t>1/27/13</a:t>
             </a:fld>
             <a:endParaRPr lang="en-US"/>
           </a:p>
@@ -3082,7 +3079,7 @@
 </file>
 
 <file path=ppt/slides/slide1.xml><?xml version="1.0" encoding="utf-8"?>
-<p:sld xmlns:a="http://schemas.openxmlformats.org/drawingml/2006/main" xmlns:r="http://schemas.openxmlformats.org/officeDocument/2006/relationships" xmlns:p="http://schemas.openxmlformats.org/presentationml/2006/main">
+<p:sld xmlns:a="http://schemas.openxmlformats.org/drawingml/2006/main" xmlns:p="http://schemas.openxmlformats.org/presentationml/2006/main" xmlns:r="http://schemas.openxmlformats.org/officeDocument/2006/relationships">
   <p:cSld>
     <p:bg>
       <p:bgPr>
@@ -3098,14 +3095,7 @@
         <p:cNvGrpSpPr/>
         <p:nvPr/>
       </p:nvGrpSpPr>
-      <p:grpSpPr>
-        <a:xfrm>
-          <a:off x="0" y="0"/>
-          <a:ext cx="0" cy="0"/>
-          <a:chOff x="0" y="0"/>
-          <a:chExt cx="0" cy="0"/>
-        </a:xfrm>
-      </p:grpSpPr>
+      <p:grpSpPr/>
       <p:sp>
         <p:nvSpPr>
           <p:cNvPr id="2" name="Rectangle 1"/>
@@ -3148,7 +3138,6 @@
           <a:lstStyle/>
           <a:p>
             <a:pPr algn="ctr"/>
-            <a:endParaRPr/>
           </a:p>
         </p:txBody>
       </p:sp>
@@ -3160,8 +3149,8 @@
         </p:nvSpPr>
         <p:spPr>
           <a:xfrm>
-            <a:off x="502920" y="347472"/>
-            <a:ext cx="7498079" cy="438912"/>
+            <a:off x="502920" y="310896"/>
+            <a:ext cx="8046720" cy="438912"/>
           </a:xfrm>
           <a:prstGeom prst="rect">
             <a:avLst/>
@@ -3169,7 +3158,7 @@
           <a:noFill/>
         </p:spPr>
         <p:txBody>
-          <a:bodyPr wrap="none" lIns="0" tIns="0" rIns="0" bIns="0" anchor="ctr">
+          <a:bodyPr wrap="none" lIns="0" rIns="0" tIns="0" bIns="0" anchor="ctr">
             <a:spAutoFit/>
           </a:bodyPr>
           <a:lstStyle/>
@@ -3182,7 +3171,7 @@
                 </a:solidFill>
                 <a:latin typeface="Microsoft JhengHei"/>
               </a:rPr>
-              <a:t>台灣地震最大震度｜決策樹分類結果</a:t>
+              <a:t>台灣地震最大震度｜兩模型時間外推比較</a:t>
             </a:r>
           </a:p>
         </p:txBody>
@@ -3195,8 +3184,8 @@
         </p:nvSpPr>
         <p:spPr>
           <a:xfrm>
-            <a:off x="521207" y="804672"/>
-            <a:ext cx="7680960" cy="228600"/>
+            <a:off x="521207" y="795528"/>
+            <a:ext cx="10972800" cy="228600"/>
           </a:xfrm>
           <a:prstGeom prst="rect">
             <a:avLst/>
@@ -3204,7 +3193,7 @@
           <a:noFill/>
         </p:spPr>
         <p:txBody>
-          <a:bodyPr wrap="none" lIns="0" tIns="0" rIns="0" bIns="0" anchor="ctr">
+          <a:bodyPr wrap="none" lIns="0" rIns="0" tIns="0" bIns="0" anchor="ctr">
             <a:spAutoFit/>
           </a:bodyPr>
           <a:lstStyle/>
@@ -3217,7 +3206,7 @@
                 </a:solidFill>
                 <a:latin typeface="Microsoft JhengHei"/>
               </a:rPr>
-              <a:t>時間外推驗證：以 1995–2023 訓練，2024–2026 測試</a:t>
+              <a:t>共同評估｜訓練 1995–2023（13,617 筆）｜測試 2024–2026（3,039 筆）</a:t>
             </a:r>
           </a:p>
         </p:txBody>
@@ -3230,8 +3219,8 @@
         </p:nvSpPr>
         <p:spPr>
           <a:xfrm>
-            <a:off x="502920" y="1234440"/>
-            <a:ext cx="1600200" cy="850392"/>
+            <a:off x="502920" y="1417320"/>
+            <a:ext cx="3429000" cy="4498848"/>
           </a:xfrm>
           <a:prstGeom prst="roundRect">
             <a:avLst/>
@@ -3264,7 +3253,6 @@
           <a:lstStyle/>
           <a:p>
             <a:pPr algn="ctr"/>
-            <a:endParaRPr/>
           </a:p>
         </p:txBody>
       </p:sp>
@@ -3276,8 +3264,8 @@
         </p:nvSpPr>
         <p:spPr>
           <a:xfrm>
-            <a:off x="667512" y="1325880"/>
-            <a:ext cx="1271016" cy="201168"/>
+            <a:off x="704088" y="1581912"/>
+            <a:ext cx="3017520" cy="283464"/>
           </a:xfrm>
           <a:prstGeom prst="rect">
             <a:avLst/>
@@ -3285,20 +3273,20 @@
           <a:noFill/>
         </p:spPr>
         <p:txBody>
-          <a:bodyPr wrap="none" lIns="0" tIns="0" rIns="0" bIns="0" anchor="ctr">
+          <a:bodyPr wrap="none" lIns="0" rIns="0" tIns="0" bIns="0" anchor="ctr">
             <a:spAutoFit/>
           </a:bodyPr>
           <a:lstStyle/>
           <a:p>
             <a:pPr algn="l"/>
             <a:r>
-              <a:rPr sz="900" b="0">
-                <a:solidFill>
-                  <a:srgbClr val="667280"/>
+              <a:rPr sz="1600" b="1">
+                <a:solidFill>
+                  <a:srgbClr val="1F807D"/>
                 </a:solidFill>
                 <a:latin typeface="Microsoft JhengHei"/>
               </a:rPr>
-              <a:t>整體準確率</a:t>
+              <a:t>決策樹</a:t>
             </a:r>
           </a:p>
         </p:txBody>
@@ -3311,8 +3299,8 @@
         </p:nvSpPr>
         <p:spPr>
           <a:xfrm>
-            <a:off x="667512" y="1517904"/>
-            <a:ext cx="1271016" cy="310896"/>
+            <a:off x="704088" y="1901952"/>
+            <a:ext cx="1481328" cy="228600"/>
           </a:xfrm>
           <a:prstGeom prst="rect">
             <a:avLst/>
@@ -3320,7 +3308,42 @@
           <a:noFill/>
         </p:spPr>
         <p:txBody>
-          <a:bodyPr wrap="none" lIns="0" tIns="0" rIns="0" bIns="0" anchor="ctr">
+          <a:bodyPr wrap="none" lIns="0" rIns="0" tIns="0" bIns="0" anchor="ctr">
+            <a:spAutoFit/>
+          </a:bodyPr>
+          <a:lstStyle/>
+          <a:p>
+            <a:pPr algn="l"/>
+            <a:r>
+              <a:rPr sz="850" b="0">
+                <a:solidFill>
+                  <a:srgbClr val="667280"/>
+                </a:solidFill>
+                <a:latin typeface="Microsoft JhengHei"/>
+              </a:rPr>
+              <a:t>Accuracy</a:t>
+            </a:r>
+          </a:p>
+        </p:txBody>
+      </p:sp>
+      <p:sp>
+        <p:nvSpPr>
+          <p:cNvPr id="8" name="TextBox 7"/>
+          <p:cNvSpPr txBox="1"/>
+          <p:nvPr/>
+        </p:nvSpPr>
+        <p:spPr>
+          <a:xfrm>
+            <a:off x="704088" y="2112264"/>
+            <a:ext cx="1481328" cy="329184"/>
+          </a:xfrm>
+          <a:prstGeom prst="rect">
+            <a:avLst/>
+          </a:prstGeom>
+          <a:noFill/>
+        </p:spPr>
+        <p:txBody>
+          <a:bodyPr wrap="none" lIns="0" rIns="0" tIns="0" bIns="0" anchor="ctr">
             <a:spAutoFit/>
           </a:bodyPr>
           <a:lstStyle/>
@@ -3340,14 +3363,14 @@
       </p:sp>
       <p:sp>
         <p:nvSpPr>
-          <p:cNvPr id="8" name="TextBox 7"/>
+          <p:cNvPr id="9" name="TextBox 8"/>
           <p:cNvSpPr txBox="1"/>
           <p:nvPr/>
         </p:nvSpPr>
         <p:spPr>
           <a:xfrm>
-            <a:off x="667512" y="1847088"/>
-            <a:ext cx="1271016" cy="146304"/>
+            <a:off x="2267712" y="1901952"/>
+            <a:ext cx="1463040" cy="228600"/>
           </a:xfrm>
           <a:prstGeom prst="rect">
             <a:avLst/>
@@ -3355,34 +3378,734 @@
           <a:noFill/>
         </p:spPr>
         <p:txBody>
-          <a:bodyPr wrap="none" lIns="0" tIns="0" rIns="0" bIns="0" anchor="ctr">
+          <a:bodyPr wrap="none" lIns="0" rIns="0" tIns="0" bIns="0" anchor="ctr">
             <a:spAutoFit/>
           </a:bodyPr>
           <a:lstStyle/>
           <a:p>
             <a:pPr algn="l"/>
             <a:r>
-              <a:rPr sz="750" b="0">
+              <a:rPr sz="850" b="0">
                 <a:solidFill>
                   <a:srgbClr val="667280"/>
                 </a:solidFill>
                 <a:latin typeface="Microsoft JhengHei"/>
               </a:rPr>
-              <a:t>chronological holdout</a:t>
-            </a:r>
-          </a:p>
-        </p:txBody>
-      </p:sp>
-      <p:sp>
-        <p:nvSpPr>
-          <p:cNvPr id="9" name="Rounded Rectangle 8"/>
+              <a:t>Macro Recall</a:t>
+            </a:r>
+          </a:p>
+        </p:txBody>
+      </p:sp>
+      <p:sp>
+        <p:nvSpPr>
+          <p:cNvPr id="10" name="TextBox 9"/>
+          <p:cNvSpPr txBox="1"/>
+          <p:nvPr/>
+        </p:nvSpPr>
+        <p:spPr>
+          <a:xfrm>
+            <a:off x="2267712" y="2112264"/>
+            <a:ext cx="1463040" cy="329184"/>
+          </a:xfrm>
+          <a:prstGeom prst="rect">
+            <a:avLst/>
+          </a:prstGeom>
+          <a:noFill/>
+        </p:spPr>
+        <p:txBody>
+          <a:bodyPr wrap="none" lIns="0" rIns="0" tIns="0" bIns="0" anchor="ctr">
+            <a:spAutoFit/>
+          </a:bodyPr>
+          <a:lstStyle/>
+          <a:p>
+            <a:pPr algn="l"/>
+            <a:r>
+              <a:rPr sz="1800" b="1">
+                <a:solidFill>
+                  <a:srgbClr val="222B36"/>
+                </a:solidFill>
+                <a:latin typeface="Microsoft JhengHei"/>
+              </a:rPr>
+              <a:t>30.43%</a:t>
+            </a:r>
+          </a:p>
+        </p:txBody>
+      </p:sp>
+      <p:sp>
+        <p:nvSpPr>
+          <p:cNvPr id="11" name="TextBox 10"/>
+          <p:cNvSpPr txBox="1"/>
+          <p:nvPr/>
+        </p:nvSpPr>
+        <p:spPr>
+          <a:xfrm>
+            <a:off x="704088" y="2587752"/>
+            <a:ext cx="2926080" cy="228600"/>
+          </a:xfrm>
+          <a:prstGeom prst="rect">
+            <a:avLst/>
+          </a:prstGeom>
+          <a:noFill/>
+        </p:spPr>
+        <p:txBody>
+          <a:bodyPr wrap="none" lIns="0" rIns="0" tIns="0" bIns="0" anchor="ctr">
+            <a:spAutoFit/>
+          </a:bodyPr>
+          <a:lstStyle/>
+          <a:p>
+            <a:pPr algn="l"/>
+            <a:r>
+              <a:rPr sz="900" b="1">
+                <a:solidFill>
+                  <a:srgbClr val="132338"/>
+                </a:solidFill>
+                <a:latin typeface="Microsoft JhengHei"/>
+              </a:rPr>
+              <a:t>震度   Recall（support）</a:t>
+            </a:r>
+          </a:p>
+        </p:txBody>
+      </p:sp>
+      <p:sp>
+        <p:nvSpPr>
+          <p:cNvPr id="12" name="TextBox 11"/>
+          <p:cNvSpPr txBox="1"/>
+          <p:nvPr/>
+        </p:nvSpPr>
+        <p:spPr>
+          <a:xfrm>
+            <a:off x="722376" y="2862072"/>
+            <a:ext cx="274320" cy="192024"/>
+          </a:xfrm>
+          <a:prstGeom prst="rect">
+            <a:avLst/>
+          </a:prstGeom>
+          <a:noFill/>
+        </p:spPr>
+        <p:txBody>
+          <a:bodyPr wrap="none" lIns="0" rIns="0" tIns="0" bIns="0" anchor="ctr">
+            <a:spAutoFit/>
+          </a:bodyPr>
+          <a:lstStyle/>
+          <a:p>
+            <a:pPr algn="l"/>
+            <a:r>
+              <a:rPr sz="850" b="1">
+                <a:solidFill>
+                  <a:srgbClr val="132338"/>
+                </a:solidFill>
+                <a:latin typeface="Microsoft JhengHei"/>
+              </a:rPr>
+              <a:t>0</a:t>
+            </a:r>
+          </a:p>
+        </p:txBody>
+      </p:sp>
+      <p:sp>
+        <p:nvSpPr>
+          <p:cNvPr id="13" name="TextBox 12"/>
+          <p:cNvSpPr txBox="1"/>
+          <p:nvPr/>
+        </p:nvSpPr>
+        <p:spPr>
+          <a:xfrm>
+            <a:off x="1069848" y="2862072"/>
+            <a:ext cx="1325880" cy="192024"/>
+          </a:xfrm>
+          <a:prstGeom prst="rect">
+            <a:avLst/>
+          </a:prstGeom>
+          <a:noFill/>
+        </p:spPr>
+        <p:txBody>
+          <a:bodyPr wrap="none" lIns="0" rIns="0" tIns="0" bIns="0" anchor="ctr">
+            <a:spAutoFit/>
+          </a:bodyPr>
+          <a:lstStyle/>
+          <a:p>
+            <a:pPr algn="l"/>
+            <a:r>
+              <a:rPr sz="850" b="0">
+                <a:solidFill>
+                  <a:srgbClr val="222B36"/>
+                </a:solidFill>
+                <a:latin typeface="Microsoft JhengHei"/>
+              </a:rPr>
+              <a:t>0.0%（1）</a:t>
+            </a:r>
+          </a:p>
+        </p:txBody>
+      </p:sp>
+      <p:sp>
+        <p:nvSpPr>
+          <p:cNvPr id="14" name="TextBox 13"/>
+          <p:cNvSpPr txBox="1"/>
+          <p:nvPr/>
+        </p:nvSpPr>
+        <p:spPr>
+          <a:xfrm>
+            <a:off x="722376" y="3145536"/>
+            <a:ext cx="274320" cy="192024"/>
+          </a:xfrm>
+          <a:prstGeom prst="rect">
+            <a:avLst/>
+          </a:prstGeom>
+          <a:noFill/>
+        </p:spPr>
+        <p:txBody>
+          <a:bodyPr wrap="none" lIns="0" rIns="0" tIns="0" bIns="0" anchor="ctr">
+            <a:spAutoFit/>
+          </a:bodyPr>
+          <a:lstStyle/>
+          <a:p>
+            <a:pPr algn="l"/>
+            <a:r>
+              <a:rPr sz="850" b="1">
+                <a:solidFill>
+                  <a:srgbClr val="132338"/>
+                </a:solidFill>
+                <a:latin typeface="Microsoft JhengHei"/>
+              </a:rPr>
+              <a:t>1</a:t>
+            </a:r>
+          </a:p>
+        </p:txBody>
+      </p:sp>
+      <p:sp>
+        <p:nvSpPr>
+          <p:cNvPr id="15" name="TextBox 14"/>
+          <p:cNvSpPr txBox="1"/>
+          <p:nvPr/>
+        </p:nvSpPr>
+        <p:spPr>
+          <a:xfrm>
+            <a:off x="1069848" y="3145536"/>
+            <a:ext cx="1325880" cy="192024"/>
+          </a:xfrm>
+          <a:prstGeom prst="rect">
+            <a:avLst/>
+          </a:prstGeom>
+          <a:noFill/>
+        </p:spPr>
+        <p:txBody>
+          <a:bodyPr wrap="none" lIns="0" rIns="0" tIns="0" bIns="0" anchor="ctr">
+            <a:spAutoFit/>
+          </a:bodyPr>
+          <a:lstStyle/>
+          <a:p>
+            <a:pPr algn="l"/>
+            <a:r>
+              <a:rPr sz="850" b="0">
+                <a:solidFill>
+                  <a:srgbClr val="222B36"/>
+                </a:solidFill>
+                <a:latin typeface="Microsoft JhengHei"/>
+              </a:rPr>
+              <a:t>26.3%（289）</a:t>
+            </a:r>
+          </a:p>
+        </p:txBody>
+      </p:sp>
+      <p:sp>
+        <p:nvSpPr>
+          <p:cNvPr id="16" name="TextBox 15"/>
+          <p:cNvSpPr txBox="1"/>
+          <p:nvPr/>
+        </p:nvSpPr>
+        <p:spPr>
+          <a:xfrm>
+            <a:off x="722376" y="3429000"/>
+            <a:ext cx="274320" cy="192024"/>
+          </a:xfrm>
+          <a:prstGeom prst="rect">
+            <a:avLst/>
+          </a:prstGeom>
+          <a:noFill/>
+        </p:spPr>
+        <p:txBody>
+          <a:bodyPr wrap="none" lIns="0" rIns="0" tIns="0" bIns="0" anchor="ctr">
+            <a:spAutoFit/>
+          </a:bodyPr>
+          <a:lstStyle/>
+          <a:p>
+            <a:pPr algn="l"/>
+            <a:r>
+              <a:rPr sz="850" b="1">
+                <a:solidFill>
+                  <a:srgbClr val="132338"/>
+                </a:solidFill>
+                <a:latin typeface="Microsoft JhengHei"/>
+              </a:rPr>
+              <a:t>2</a:t>
+            </a:r>
+          </a:p>
+        </p:txBody>
+      </p:sp>
+      <p:sp>
+        <p:nvSpPr>
+          <p:cNvPr id="17" name="TextBox 16"/>
+          <p:cNvSpPr txBox="1"/>
+          <p:nvPr/>
+        </p:nvSpPr>
+        <p:spPr>
+          <a:xfrm>
+            <a:off x="1069848" y="3429000"/>
+            <a:ext cx="1325880" cy="192024"/>
+          </a:xfrm>
+          <a:prstGeom prst="rect">
+            <a:avLst/>
+          </a:prstGeom>
+          <a:noFill/>
+        </p:spPr>
+        <p:txBody>
+          <a:bodyPr wrap="none" lIns="0" rIns="0" tIns="0" bIns="0" anchor="ctr">
+            <a:spAutoFit/>
+          </a:bodyPr>
+          <a:lstStyle/>
+          <a:p>
+            <a:pPr algn="l"/>
+            <a:r>
+              <a:rPr sz="850" b="0">
+                <a:solidFill>
+                  <a:srgbClr val="222B36"/>
+                </a:solidFill>
+                <a:latin typeface="Microsoft JhengHei"/>
+              </a:rPr>
+              <a:t>25.3%（1,278）</a:t>
+            </a:r>
+          </a:p>
+        </p:txBody>
+      </p:sp>
+      <p:sp>
+        <p:nvSpPr>
+          <p:cNvPr id="18" name="TextBox 17"/>
+          <p:cNvSpPr txBox="1"/>
+          <p:nvPr/>
+        </p:nvSpPr>
+        <p:spPr>
+          <a:xfrm>
+            <a:off x="722376" y="3712463"/>
+            <a:ext cx="274320" cy="192024"/>
+          </a:xfrm>
+          <a:prstGeom prst="rect">
+            <a:avLst/>
+          </a:prstGeom>
+          <a:noFill/>
+        </p:spPr>
+        <p:txBody>
+          <a:bodyPr wrap="none" lIns="0" rIns="0" tIns="0" bIns="0" anchor="ctr">
+            <a:spAutoFit/>
+          </a:bodyPr>
+          <a:lstStyle/>
+          <a:p>
+            <a:pPr algn="l"/>
+            <a:r>
+              <a:rPr sz="850" b="1">
+                <a:solidFill>
+                  <a:srgbClr val="132338"/>
+                </a:solidFill>
+                <a:latin typeface="Microsoft JhengHei"/>
+              </a:rPr>
+              <a:t>3</a:t>
+            </a:r>
+          </a:p>
+        </p:txBody>
+      </p:sp>
+      <p:sp>
+        <p:nvSpPr>
+          <p:cNvPr id="19" name="TextBox 18"/>
+          <p:cNvSpPr txBox="1"/>
+          <p:nvPr/>
+        </p:nvSpPr>
+        <p:spPr>
+          <a:xfrm>
+            <a:off x="1069848" y="3712463"/>
+            <a:ext cx="1325880" cy="192024"/>
+          </a:xfrm>
+          <a:prstGeom prst="rect">
+            <a:avLst/>
+          </a:prstGeom>
+          <a:noFill/>
+        </p:spPr>
+        <p:txBody>
+          <a:bodyPr wrap="none" lIns="0" rIns="0" tIns="0" bIns="0" anchor="ctr">
+            <a:spAutoFit/>
+          </a:bodyPr>
+          <a:lstStyle/>
+          <a:p>
+            <a:pPr algn="l"/>
+            <a:r>
+              <a:rPr sz="850" b="0">
+                <a:solidFill>
+                  <a:srgbClr val="222B36"/>
+                </a:solidFill>
+                <a:latin typeface="Microsoft JhengHei"/>
+              </a:rPr>
+              <a:t>28.6%（910）</a:t>
+            </a:r>
+          </a:p>
+        </p:txBody>
+      </p:sp>
+      <p:sp>
+        <p:nvSpPr>
+          <p:cNvPr id="20" name="TextBox 19"/>
+          <p:cNvSpPr txBox="1"/>
+          <p:nvPr/>
+        </p:nvSpPr>
+        <p:spPr>
+          <a:xfrm>
+            <a:off x="722376" y="3995928"/>
+            <a:ext cx="274320" cy="192024"/>
+          </a:xfrm>
+          <a:prstGeom prst="rect">
+            <a:avLst/>
+          </a:prstGeom>
+          <a:noFill/>
+        </p:spPr>
+        <p:txBody>
+          <a:bodyPr wrap="none" lIns="0" rIns="0" tIns="0" bIns="0" anchor="ctr">
+            <a:spAutoFit/>
+          </a:bodyPr>
+          <a:lstStyle/>
+          <a:p>
+            <a:pPr algn="l"/>
+            <a:r>
+              <a:rPr sz="850" b="1">
+                <a:solidFill>
+                  <a:srgbClr val="132338"/>
+                </a:solidFill>
+                <a:latin typeface="Microsoft JhengHei"/>
+              </a:rPr>
+              <a:t>4</a:t>
+            </a:r>
+          </a:p>
+        </p:txBody>
+      </p:sp>
+      <p:sp>
+        <p:nvSpPr>
+          <p:cNvPr id="21" name="TextBox 20"/>
+          <p:cNvSpPr txBox="1"/>
+          <p:nvPr/>
+        </p:nvSpPr>
+        <p:spPr>
+          <a:xfrm>
+            <a:off x="1069848" y="3995928"/>
+            <a:ext cx="1325880" cy="192024"/>
+          </a:xfrm>
+          <a:prstGeom prst="rect">
+            <a:avLst/>
+          </a:prstGeom>
+          <a:noFill/>
+        </p:spPr>
+        <p:txBody>
+          <a:bodyPr wrap="none" lIns="0" rIns="0" tIns="0" bIns="0" anchor="ctr">
+            <a:spAutoFit/>
+          </a:bodyPr>
+          <a:lstStyle/>
+          <a:p>
+            <a:pPr algn="l"/>
+            <a:r>
+              <a:rPr sz="850" b="0">
+                <a:solidFill>
+                  <a:srgbClr val="222B36"/>
+                </a:solidFill>
+                <a:latin typeface="Microsoft JhengHei"/>
+              </a:rPr>
+              <a:t>35.5%（538）</a:t>
+            </a:r>
+          </a:p>
+        </p:txBody>
+      </p:sp>
+      <p:sp>
+        <p:nvSpPr>
+          <p:cNvPr id="22" name="TextBox 21"/>
+          <p:cNvSpPr txBox="1"/>
+          <p:nvPr/>
+        </p:nvSpPr>
+        <p:spPr>
+          <a:xfrm>
+            <a:off x="722376" y="4279392"/>
+            <a:ext cx="274320" cy="192024"/>
+          </a:xfrm>
+          <a:prstGeom prst="rect">
+            <a:avLst/>
+          </a:prstGeom>
+          <a:noFill/>
+        </p:spPr>
+        <p:txBody>
+          <a:bodyPr wrap="none" lIns="0" rIns="0" tIns="0" bIns="0" anchor="ctr">
+            <a:spAutoFit/>
+          </a:bodyPr>
+          <a:lstStyle/>
+          <a:p>
+            <a:pPr algn="l"/>
+            <a:r>
+              <a:rPr sz="850" b="1">
+                <a:solidFill>
+                  <a:srgbClr val="132338"/>
+                </a:solidFill>
+                <a:latin typeface="Microsoft JhengHei"/>
+              </a:rPr>
+              <a:t>5</a:t>
+            </a:r>
+          </a:p>
+        </p:txBody>
+      </p:sp>
+      <p:sp>
+        <p:nvSpPr>
+          <p:cNvPr id="23" name="TextBox 22"/>
+          <p:cNvSpPr txBox="1"/>
+          <p:nvPr/>
+        </p:nvSpPr>
+        <p:spPr>
+          <a:xfrm>
+            <a:off x="1069848" y="4279392"/>
+            <a:ext cx="1325880" cy="192024"/>
+          </a:xfrm>
+          <a:prstGeom prst="rect">
+            <a:avLst/>
+          </a:prstGeom>
+          <a:noFill/>
+        </p:spPr>
+        <p:txBody>
+          <a:bodyPr wrap="none" lIns="0" rIns="0" tIns="0" bIns="0" anchor="ctr">
+            <a:spAutoFit/>
+          </a:bodyPr>
+          <a:lstStyle/>
+          <a:p>
+            <a:pPr algn="l"/>
+            <a:r>
+              <a:rPr sz="850" b="0">
+                <a:solidFill>
+                  <a:srgbClr val="222B36"/>
+                </a:solidFill>
+                <a:latin typeface="Microsoft JhengHei"/>
+              </a:rPr>
+              <a:t>47.4%（19）</a:t>
+            </a:r>
+          </a:p>
+        </p:txBody>
+      </p:sp>
+      <p:sp>
+        <p:nvSpPr>
+          <p:cNvPr id="24" name="TextBox 23"/>
+          <p:cNvSpPr txBox="1"/>
+          <p:nvPr/>
+        </p:nvSpPr>
+        <p:spPr>
+          <a:xfrm>
+            <a:off x="722376" y="4562856"/>
+            <a:ext cx="274320" cy="192024"/>
+          </a:xfrm>
+          <a:prstGeom prst="rect">
+            <a:avLst/>
+          </a:prstGeom>
+          <a:noFill/>
+        </p:spPr>
+        <p:txBody>
+          <a:bodyPr wrap="none" lIns="0" rIns="0" tIns="0" bIns="0" anchor="ctr">
+            <a:spAutoFit/>
+          </a:bodyPr>
+          <a:lstStyle/>
+          <a:p>
+            <a:pPr algn="l"/>
+            <a:r>
+              <a:rPr sz="850" b="1">
+                <a:solidFill>
+                  <a:srgbClr val="132338"/>
+                </a:solidFill>
+                <a:latin typeface="Microsoft JhengHei"/>
+              </a:rPr>
+              <a:t>6</a:t>
+            </a:r>
+          </a:p>
+        </p:txBody>
+      </p:sp>
+      <p:sp>
+        <p:nvSpPr>
+          <p:cNvPr id="25" name="TextBox 24"/>
+          <p:cNvSpPr txBox="1"/>
+          <p:nvPr/>
+        </p:nvSpPr>
+        <p:spPr>
+          <a:xfrm>
+            <a:off x="1069848" y="4562856"/>
+            <a:ext cx="1325880" cy="192024"/>
+          </a:xfrm>
+          <a:prstGeom prst="rect">
+            <a:avLst/>
+          </a:prstGeom>
+          <a:noFill/>
+        </p:spPr>
+        <p:txBody>
+          <a:bodyPr wrap="none" lIns="0" rIns="0" tIns="0" bIns="0" anchor="ctr">
+            <a:spAutoFit/>
+          </a:bodyPr>
+          <a:lstStyle/>
+          <a:p>
+            <a:pPr algn="l"/>
+            <a:r>
+              <a:rPr sz="850" b="0">
+                <a:solidFill>
+                  <a:srgbClr val="222B36"/>
+                </a:solidFill>
+                <a:latin typeface="Microsoft JhengHei"/>
+              </a:rPr>
+              <a:t>50.0%（4）</a:t>
+            </a:r>
+          </a:p>
+        </p:txBody>
+      </p:sp>
+      <p:sp>
+        <p:nvSpPr>
+          <p:cNvPr id="26" name="TextBox 25"/>
+          <p:cNvSpPr txBox="1"/>
+          <p:nvPr/>
+        </p:nvSpPr>
+        <p:spPr>
+          <a:xfrm>
+            <a:off x="722376" y="4846320"/>
+            <a:ext cx="274320" cy="192024"/>
+          </a:xfrm>
+          <a:prstGeom prst="rect">
+            <a:avLst/>
+          </a:prstGeom>
+          <a:noFill/>
+        </p:spPr>
+        <p:txBody>
+          <a:bodyPr wrap="none" lIns="0" rIns="0" tIns="0" bIns="0" anchor="ctr">
+            <a:spAutoFit/>
+          </a:bodyPr>
+          <a:lstStyle/>
+          <a:p>
+            <a:pPr algn="l"/>
+            <a:r>
+              <a:rPr sz="850" b="1">
+                <a:solidFill>
+                  <a:srgbClr val="132338"/>
+                </a:solidFill>
+                <a:latin typeface="Microsoft JhengHei"/>
+              </a:rPr>
+              <a:t>7</a:t>
+            </a:r>
+          </a:p>
+        </p:txBody>
+      </p:sp>
+      <p:sp>
+        <p:nvSpPr>
+          <p:cNvPr id="27" name="TextBox 26"/>
+          <p:cNvSpPr txBox="1"/>
+          <p:nvPr/>
+        </p:nvSpPr>
+        <p:spPr>
+          <a:xfrm>
+            <a:off x="1069848" y="4846320"/>
+            <a:ext cx="1325880" cy="192024"/>
+          </a:xfrm>
+          <a:prstGeom prst="rect">
+            <a:avLst/>
+          </a:prstGeom>
+          <a:noFill/>
+        </p:spPr>
+        <p:txBody>
+          <a:bodyPr wrap="none" lIns="0" rIns="0" tIns="0" bIns="0" anchor="ctr">
+            <a:spAutoFit/>
+          </a:bodyPr>
+          <a:lstStyle/>
+          <a:p>
+            <a:pPr algn="l"/>
+            <a:r>
+              <a:rPr sz="850" b="0">
+                <a:solidFill>
+                  <a:srgbClr val="222B36"/>
+                </a:solidFill>
+                <a:latin typeface="Microsoft JhengHei"/>
+              </a:rPr>
+              <a:t>N/A（0）</a:t>
+            </a:r>
+          </a:p>
+        </p:txBody>
+      </p:sp>
+      <p:sp>
+        <p:nvSpPr>
+          <p:cNvPr id="28" name="TextBox 27"/>
+          <p:cNvSpPr txBox="1"/>
+          <p:nvPr/>
+        </p:nvSpPr>
+        <p:spPr>
+          <a:xfrm>
+            <a:off x="704088" y="5230368"/>
+            <a:ext cx="2999232" cy="411480"/>
+          </a:xfrm>
+          <a:prstGeom prst="rect">
+            <a:avLst/>
+          </a:prstGeom>
+          <a:noFill/>
+        </p:spPr>
+        <p:txBody>
+          <a:bodyPr wrap="none" lIns="0" rIns="0" tIns="0" bIns="0" anchor="ctr">
+            <a:spAutoFit/>
+          </a:bodyPr>
+          <a:lstStyle/>
+          <a:p>
+            <a:pPr algn="l"/>
+            <a:r>
+              <a:rPr sz="760" b="0">
+                <a:solidFill>
+                  <a:srgbClr val="667280"/>
+                </a:solidFill>
+                <a:latin typeface="Microsoft JhengHei"/>
+              </a:rPr>
+              <a:t>選定參數｜max_depth=12 · min_samples_leaf=1</a:t>
+            </a:r>
+          </a:p>
+        </p:txBody>
+      </p:sp>
+      <p:sp>
+        <p:nvSpPr>
+          <p:cNvPr id="29" name="TextBox 28"/>
+          <p:cNvSpPr txBox="1"/>
+          <p:nvPr/>
+        </p:nvSpPr>
+        <p:spPr>
+          <a:xfrm>
+            <a:off x="704088" y="5614416"/>
+            <a:ext cx="2999232" cy="182880"/>
+          </a:xfrm>
+          <a:prstGeom prst="rect">
+            <a:avLst/>
+          </a:prstGeom>
+          <a:noFill/>
+        </p:spPr>
+        <p:txBody>
+          <a:bodyPr wrap="none" lIns="0" rIns="0" tIns="0" bIns="0" anchor="ctr">
+            <a:spAutoFit/>
+          </a:bodyPr>
+          <a:lstStyle/>
+          <a:p>
+            <a:pPr algn="l"/>
+            <a:r>
+              <a:rPr sz="720" b="0">
+                <a:solidFill>
+                  <a:srgbClr val="667280"/>
+                </a:solidFill>
+                <a:latin typeface="Microsoft JhengHei"/>
+              </a:rPr>
+              <a:t>驗證 Macro Recall 32.87% · Accuracy 34.65%</a:t>
+            </a:r>
+          </a:p>
+        </p:txBody>
+      </p:sp>
+      <p:sp>
+        <p:nvSpPr>
+          <p:cNvPr id="30" name="Rounded Rectangle 29"/>
           <p:cNvSpPr/>
           <p:nvPr/>
         </p:nvSpPr>
         <p:spPr>
           <a:xfrm>
-            <a:off x="2212848" y="1234440"/>
-            <a:ext cx="1325880" cy="850392"/>
+            <a:off x="4069080" y="1417320"/>
+            <a:ext cx="3429000" cy="4498848"/>
           </a:xfrm>
           <a:prstGeom prst="roundRect">
             <a:avLst/>
@@ -3415,20 +4138,19 @@
           <a:lstStyle/>
           <a:p>
             <a:pPr algn="ctr"/>
-            <a:endParaRPr/>
-          </a:p>
-        </p:txBody>
-      </p:sp>
-      <p:sp>
-        <p:nvSpPr>
-          <p:cNvPr id="10" name="TextBox 9"/>
+          </a:p>
+        </p:txBody>
+      </p:sp>
+      <p:sp>
+        <p:nvSpPr>
+          <p:cNvPr id="31" name="TextBox 30"/>
           <p:cNvSpPr txBox="1"/>
           <p:nvPr/>
         </p:nvSpPr>
         <p:spPr>
           <a:xfrm>
-            <a:off x="2377440" y="1325880"/>
-            <a:ext cx="996695" cy="201168"/>
+            <a:off x="4270248" y="1581912"/>
+            <a:ext cx="3017520" cy="283464"/>
           </a:xfrm>
           <a:prstGeom prst="rect">
             <a:avLst/>
@@ -3436,34 +4158,34 @@
           <a:noFill/>
         </p:spPr>
         <p:txBody>
-          <a:bodyPr wrap="none" lIns="0" tIns="0" rIns="0" bIns="0" anchor="ctr">
+          <a:bodyPr wrap="none" lIns="0" rIns="0" tIns="0" bIns="0" anchor="ctr">
             <a:spAutoFit/>
           </a:bodyPr>
           <a:lstStyle/>
           <a:p>
             <a:pPr algn="l"/>
             <a:r>
-              <a:rPr sz="900" b="0">
-                <a:solidFill>
-                  <a:srgbClr val="667280"/>
+              <a:rPr sz="1600" b="1">
+                <a:solidFill>
+                  <a:srgbClr val="DA9335"/>
                 </a:solidFill>
                 <a:latin typeface="Microsoft JhengHei"/>
               </a:rPr>
-              <a:t>訓練資料</a:t>
-            </a:r>
-          </a:p>
-        </p:txBody>
-      </p:sp>
-      <p:sp>
-        <p:nvSpPr>
-          <p:cNvPr id="11" name="TextBox 10"/>
+              <a:t>隨機森林</a:t>
+            </a:r>
+          </a:p>
+        </p:txBody>
+      </p:sp>
+      <p:sp>
+        <p:nvSpPr>
+          <p:cNvPr id="32" name="TextBox 31"/>
           <p:cNvSpPr txBox="1"/>
           <p:nvPr/>
         </p:nvSpPr>
         <p:spPr>
           <a:xfrm>
-            <a:off x="2377440" y="1517904"/>
-            <a:ext cx="996695" cy="310896"/>
+            <a:off x="4270248" y="1901952"/>
+            <a:ext cx="1481328" cy="228600"/>
           </a:xfrm>
           <a:prstGeom prst="rect">
             <a:avLst/>
@@ -3471,34 +4193,34 @@
           <a:noFill/>
         </p:spPr>
         <p:txBody>
-          <a:bodyPr wrap="none" lIns="0" tIns="0" rIns="0" bIns="0" anchor="ctr">
+          <a:bodyPr wrap="none" lIns="0" rIns="0" tIns="0" bIns="0" anchor="ctr">
             <a:spAutoFit/>
           </a:bodyPr>
           <a:lstStyle/>
           <a:p>
             <a:pPr algn="l"/>
             <a:r>
-              <a:rPr sz="1800" b="1">
-                <a:solidFill>
-                  <a:srgbClr val="222B36"/>
+              <a:rPr sz="850" b="0">
+                <a:solidFill>
+                  <a:srgbClr val="667280"/>
                 </a:solidFill>
                 <a:latin typeface="Microsoft JhengHei"/>
               </a:rPr>
-              <a:t>13,617</a:t>
-            </a:r>
-          </a:p>
-        </p:txBody>
-      </p:sp>
-      <p:sp>
-        <p:nvSpPr>
-          <p:cNvPr id="12" name="TextBox 11"/>
+              <a:t>Accuracy</a:t>
+            </a:r>
+          </a:p>
+        </p:txBody>
+      </p:sp>
+      <p:sp>
+        <p:nvSpPr>
+          <p:cNvPr id="33" name="TextBox 32"/>
           <p:cNvSpPr txBox="1"/>
           <p:nvPr/>
         </p:nvSpPr>
         <p:spPr>
           <a:xfrm>
-            <a:off x="2377440" y="1847088"/>
-            <a:ext cx="996695" cy="146304"/>
+            <a:off x="4270248" y="2112264"/>
+            <a:ext cx="1481328" cy="329184"/>
           </a:xfrm>
           <a:prstGeom prst="rect">
             <a:avLst/>
@@ -3506,44 +4228,779 @@
           <a:noFill/>
         </p:spPr>
         <p:txBody>
-          <a:bodyPr wrap="none" lIns="0" tIns="0" rIns="0" bIns="0" anchor="ctr">
+          <a:bodyPr wrap="none" lIns="0" rIns="0" tIns="0" bIns="0" anchor="ctr">
             <a:spAutoFit/>
           </a:bodyPr>
           <a:lstStyle/>
           <a:p>
             <a:pPr algn="l"/>
             <a:r>
-              <a:rPr sz="750" b="0">
-                <a:solidFill>
-                  <a:srgbClr val="667280"/>
+              <a:rPr sz="1800" b="1">
+                <a:solidFill>
+                  <a:srgbClr val="222B36"/>
                 </a:solidFill>
                 <a:latin typeface="Microsoft JhengHei"/>
               </a:rPr>
-              <a:t>1995–2023</a:t>
-            </a:r>
-          </a:p>
-        </p:txBody>
-      </p:sp>
-      <p:sp>
-        <p:nvSpPr>
-          <p:cNvPr id="13" name="Rounded Rectangle 12"/>
+              <a:t>43.90%</a:t>
+            </a:r>
+          </a:p>
+        </p:txBody>
+      </p:sp>
+      <p:sp>
+        <p:nvSpPr>
+          <p:cNvPr id="34" name="TextBox 33"/>
+          <p:cNvSpPr txBox="1"/>
+          <p:nvPr/>
+        </p:nvSpPr>
+        <p:spPr>
+          <a:xfrm>
+            <a:off x="5833872" y="1901952"/>
+            <a:ext cx="1463040" cy="228600"/>
+          </a:xfrm>
+          <a:prstGeom prst="rect">
+            <a:avLst/>
+          </a:prstGeom>
+          <a:noFill/>
+        </p:spPr>
+        <p:txBody>
+          <a:bodyPr wrap="none" lIns="0" rIns="0" tIns="0" bIns="0" anchor="ctr">
+            <a:spAutoFit/>
+          </a:bodyPr>
+          <a:lstStyle/>
+          <a:p>
+            <a:pPr algn="l"/>
+            <a:r>
+              <a:rPr sz="850" b="0">
+                <a:solidFill>
+                  <a:srgbClr val="667280"/>
+                </a:solidFill>
+                <a:latin typeface="Microsoft JhengHei"/>
+              </a:rPr>
+              <a:t>Macro Recall</a:t>
+            </a:r>
+          </a:p>
+        </p:txBody>
+      </p:sp>
+      <p:sp>
+        <p:nvSpPr>
+          <p:cNvPr id="35" name="TextBox 34"/>
+          <p:cNvSpPr txBox="1"/>
+          <p:nvPr/>
+        </p:nvSpPr>
+        <p:spPr>
+          <a:xfrm>
+            <a:off x="5833872" y="2112264"/>
+            <a:ext cx="1463040" cy="329184"/>
+          </a:xfrm>
+          <a:prstGeom prst="rect">
+            <a:avLst/>
+          </a:prstGeom>
+          <a:noFill/>
+        </p:spPr>
+        <p:txBody>
+          <a:bodyPr wrap="none" lIns="0" rIns="0" tIns="0" bIns="0" anchor="ctr">
+            <a:spAutoFit/>
+          </a:bodyPr>
+          <a:lstStyle/>
+          <a:p>
+            <a:pPr algn="l"/>
+            <a:r>
+              <a:rPr sz="1800" b="1">
+                <a:solidFill>
+                  <a:srgbClr val="222B36"/>
+                </a:solidFill>
+                <a:latin typeface="Microsoft JhengHei"/>
+              </a:rPr>
+              <a:t>40.81%</a:t>
+            </a:r>
+          </a:p>
+        </p:txBody>
+      </p:sp>
+      <p:sp>
+        <p:nvSpPr>
+          <p:cNvPr id="36" name="TextBox 35"/>
+          <p:cNvSpPr txBox="1"/>
+          <p:nvPr/>
+        </p:nvSpPr>
+        <p:spPr>
+          <a:xfrm>
+            <a:off x="4270248" y="2587752"/>
+            <a:ext cx="2926080" cy="228600"/>
+          </a:xfrm>
+          <a:prstGeom prst="rect">
+            <a:avLst/>
+          </a:prstGeom>
+          <a:noFill/>
+        </p:spPr>
+        <p:txBody>
+          <a:bodyPr wrap="none" lIns="0" rIns="0" tIns="0" bIns="0" anchor="ctr">
+            <a:spAutoFit/>
+          </a:bodyPr>
+          <a:lstStyle/>
+          <a:p>
+            <a:pPr algn="l"/>
+            <a:r>
+              <a:rPr sz="900" b="1">
+                <a:solidFill>
+                  <a:srgbClr val="132338"/>
+                </a:solidFill>
+                <a:latin typeface="Microsoft JhengHei"/>
+              </a:rPr>
+              <a:t>震度   Recall（support）</a:t>
+            </a:r>
+          </a:p>
+        </p:txBody>
+      </p:sp>
+      <p:sp>
+        <p:nvSpPr>
+          <p:cNvPr id="37" name="TextBox 36"/>
+          <p:cNvSpPr txBox="1"/>
+          <p:nvPr/>
+        </p:nvSpPr>
+        <p:spPr>
+          <a:xfrm>
+            <a:off x="4288536" y="2862072"/>
+            <a:ext cx="274320" cy="192024"/>
+          </a:xfrm>
+          <a:prstGeom prst="rect">
+            <a:avLst/>
+          </a:prstGeom>
+          <a:noFill/>
+        </p:spPr>
+        <p:txBody>
+          <a:bodyPr wrap="none" lIns="0" rIns="0" tIns="0" bIns="0" anchor="ctr">
+            <a:spAutoFit/>
+          </a:bodyPr>
+          <a:lstStyle/>
+          <a:p>
+            <a:pPr algn="l"/>
+            <a:r>
+              <a:rPr sz="850" b="1">
+                <a:solidFill>
+                  <a:srgbClr val="132338"/>
+                </a:solidFill>
+                <a:latin typeface="Microsoft JhengHei"/>
+              </a:rPr>
+              <a:t>0</a:t>
+            </a:r>
+          </a:p>
+        </p:txBody>
+      </p:sp>
+      <p:sp>
+        <p:nvSpPr>
+          <p:cNvPr id="38" name="TextBox 37"/>
+          <p:cNvSpPr txBox="1"/>
+          <p:nvPr/>
+        </p:nvSpPr>
+        <p:spPr>
+          <a:xfrm>
+            <a:off x="4636008" y="2862072"/>
+            <a:ext cx="1325880" cy="192024"/>
+          </a:xfrm>
+          <a:prstGeom prst="rect">
+            <a:avLst/>
+          </a:prstGeom>
+          <a:noFill/>
+        </p:spPr>
+        <p:txBody>
+          <a:bodyPr wrap="none" lIns="0" rIns="0" tIns="0" bIns="0" anchor="ctr">
+            <a:spAutoFit/>
+          </a:bodyPr>
+          <a:lstStyle/>
+          <a:p>
+            <a:pPr algn="l"/>
+            <a:r>
+              <a:rPr sz="850" b="0">
+                <a:solidFill>
+                  <a:srgbClr val="222B36"/>
+                </a:solidFill>
+                <a:latin typeface="Microsoft JhengHei"/>
+              </a:rPr>
+              <a:t>0.0%（1）</a:t>
+            </a:r>
+          </a:p>
+        </p:txBody>
+      </p:sp>
+      <p:sp>
+        <p:nvSpPr>
+          <p:cNvPr id="39" name="TextBox 38"/>
+          <p:cNvSpPr txBox="1"/>
+          <p:nvPr/>
+        </p:nvSpPr>
+        <p:spPr>
+          <a:xfrm>
+            <a:off x="4288536" y="3145536"/>
+            <a:ext cx="274320" cy="192024"/>
+          </a:xfrm>
+          <a:prstGeom prst="rect">
+            <a:avLst/>
+          </a:prstGeom>
+          <a:noFill/>
+        </p:spPr>
+        <p:txBody>
+          <a:bodyPr wrap="none" lIns="0" rIns="0" tIns="0" bIns="0" anchor="ctr">
+            <a:spAutoFit/>
+          </a:bodyPr>
+          <a:lstStyle/>
+          <a:p>
+            <a:pPr algn="l"/>
+            <a:r>
+              <a:rPr sz="850" b="1">
+                <a:solidFill>
+                  <a:srgbClr val="132338"/>
+                </a:solidFill>
+                <a:latin typeface="Microsoft JhengHei"/>
+              </a:rPr>
+              <a:t>1</a:t>
+            </a:r>
+          </a:p>
+        </p:txBody>
+      </p:sp>
+      <p:sp>
+        <p:nvSpPr>
+          <p:cNvPr id="40" name="TextBox 39"/>
+          <p:cNvSpPr txBox="1"/>
+          <p:nvPr/>
+        </p:nvSpPr>
+        <p:spPr>
+          <a:xfrm>
+            <a:off x="4636008" y="3145536"/>
+            <a:ext cx="1325880" cy="192024"/>
+          </a:xfrm>
+          <a:prstGeom prst="rect">
+            <a:avLst/>
+          </a:prstGeom>
+          <a:noFill/>
+        </p:spPr>
+        <p:txBody>
+          <a:bodyPr wrap="none" lIns="0" rIns="0" tIns="0" bIns="0" anchor="ctr">
+            <a:spAutoFit/>
+          </a:bodyPr>
+          <a:lstStyle/>
+          <a:p>
+            <a:pPr algn="l"/>
+            <a:r>
+              <a:rPr sz="850" b="0">
+                <a:solidFill>
+                  <a:srgbClr val="222B36"/>
+                </a:solidFill>
+                <a:latin typeface="Microsoft JhengHei"/>
+              </a:rPr>
+              <a:t>19.4%（289）</a:t>
+            </a:r>
+          </a:p>
+        </p:txBody>
+      </p:sp>
+      <p:sp>
+        <p:nvSpPr>
+          <p:cNvPr id="41" name="TextBox 40"/>
+          <p:cNvSpPr txBox="1"/>
+          <p:nvPr/>
+        </p:nvSpPr>
+        <p:spPr>
+          <a:xfrm>
+            <a:off x="4288536" y="3429000"/>
+            <a:ext cx="274320" cy="192024"/>
+          </a:xfrm>
+          <a:prstGeom prst="rect">
+            <a:avLst/>
+          </a:prstGeom>
+          <a:noFill/>
+        </p:spPr>
+        <p:txBody>
+          <a:bodyPr wrap="none" lIns="0" rIns="0" tIns="0" bIns="0" anchor="ctr">
+            <a:spAutoFit/>
+          </a:bodyPr>
+          <a:lstStyle/>
+          <a:p>
+            <a:pPr algn="l"/>
+            <a:r>
+              <a:rPr sz="850" b="1">
+                <a:solidFill>
+                  <a:srgbClr val="132338"/>
+                </a:solidFill>
+                <a:latin typeface="Microsoft JhengHei"/>
+              </a:rPr>
+              <a:t>2</a:t>
+            </a:r>
+          </a:p>
+        </p:txBody>
+      </p:sp>
+      <p:sp>
+        <p:nvSpPr>
+          <p:cNvPr id="42" name="TextBox 41"/>
+          <p:cNvSpPr txBox="1"/>
+          <p:nvPr/>
+        </p:nvSpPr>
+        <p:spPr>
+          <a:xfrm>
+            <a:off x="4636008" y="3429000"/>
+            <a:ext cx="1325880" cy="192024"/>
+          </a:xfrm>
+          <a:prstGeom prst="rect">
+            <a:avLst/>
+          </a:prstGeom>
+          <a:noFill/>
+        </p:spPr>
+        <p:txBody>
+          <a:bodyPr wrap="none" lIns="0" rIns="0" tIns="0" bIns="0" anchor="ctr">
+            <a:spAutoFit/>
+          </a:bodyPr>
+          <a:lstStyle/>
+          <a:p>
+            <a:pPr algn="l"/>
+            <a:r>
+              <a:rPr sz="850" b="0">
+                <a:solidFill>
+                  <a:srgbClr val="222B36"/>
+                </a:solidFill>
+                <a:latin typeface="Microsoft JhengHei"/>
+              </a:rPr>
+              <a:t>43.2%（1,278）</a:t>
+            </a:r>
+          </a:p>
+        </p:txBody>
+      </p:sp>
+      <p:sp>
+        <p:nvSpPr>
+          <p:cNvPr id="43" name="TextBox 42"/>
+          <p:cNvSpPr txBox="1"/>
+          <p:nvPr/>
+        </p:nvSpPr>
+        <p:spPr>
+          <a:xfrm>
+            <a:off x="4288536" y="3712463"/>
+            <a:ext cx="274320" cy="192024"/>
+          </a:xfrm>
+          <a:prstGeom prst="rect">
+            <a:avLst/>
+          </a:prstGeom>
+          <a:noFill/>
+        </p:spPr>
+        <p:txBody>
+          <a:bodyPr wrap="none" lIns="0" rIns="0" tIns="0" bIns="0" anchor="ctr">
+            <a:spAutoFit/>
+          </a:bodyPr>
+          <a:lstStyle/>
+          <a:p>
+            <a:pPr algn="l"/>
+            <a:r>
+              <a:rPr sz="850" b="1">
+                <a:solidFill>
+                  <a:srgbClr val="132338"/>
+                </a:solidFill>
+                <a:latin typeface="Microsoft JhengHei"/>
+              </a:rPr>
+              <a:t>3</a:t>
+            </a:r>
+          </a:p>
+        </p:txBody>
+      </p:sp>
+      <p:sp>
+        <p:nvSpPr>
+          <p:cNvPr id="44" name="TextBox 43"/>
+          <p:cNvSpPr txBox="1"/>
+          <p:nvPr/>
+        </p:nvSpPr>
+        <p:spPr>
+          <a:xfrm>
+            <a:off x="4636008" y="3712463"/>
+            <a:ext cx="1325880" cy="192024"/>
+          </a:xfrm>
+          <a:prstGeom prst="rect">
+            <a:avLst/>
+          </a:prstGeom>
+          <a:noFill/>
+        </p:spPr>
+        <p:txBody>
+          <a:bodyPr wrap="none" lIns="0" rIns="0" tIns="0" bIns="0" anchor="ctr">
+            <a:spAutoFit/>
+          </a:bodyPr>
+          <a:lstStyle/>
+          <a:p>
+            <a:pPr algn="l"/>
+            <a:r>
+              <a:rPr sz="850" b="0">
+                <a:solidFill>
+                  <a:srgbClr val="222B36"/>
+                </a:solidFill>
+                <a:latin typeface="Microsoft JhengHei"/>
+              </a:rPr>
+              <a:t>39.8%（910）</a:t>
+            </a:r>
+          </a:p>
+        </p:txBody>
+      </p:sp>
+      <p:sp>
+        <p:nvSpPr>
+          <p:cNvPr id="45" name="TextBox 44"/>
+          <p:cNvSpPr txBox="1"/>
+          <p:nvPr/>
+        </p:nvSpPr>
+        <p:spPr>
+          <a:xfrm>
+            <a:off x="4288536" y="3995928"/>
+            <a:ext cx="274320" cy="192024"/>
+          </a:xfrm>
+          <a:prstGeom prst="rect">
+            <a:avLst/>
+          </a:prstGeom>
+          <a:noFill/>
+        </p:spPr>
+        <p:txBody>
+          <a:bodyPr wrap="none" lIns="0" rIns="0" tIns="0" bIns="0" anchor="ctr">
+            <a:spAutoFit/>
+          </a:bodyPr>
+          <a:lstStyle/>
+          <a:p>
+            <a:pPr algn="l"/>
+            <a:r>
+              <a:rPr sz="850" b="1">
+                <a:solidFill>
+                  <a:srgbClr val="132338"/>
+                </a:solidFill>
+                <a:latin typeface="Microsoft JhengHei"/>
+              </a:rPr>
+              <a:t>4</a:t>
+            </a:r>
+          </a:p>
+        </p:txBody>
+      </p:sp>
+      <p:sp>
+        <p:nvSpPr>
+          <p:cNvPr id="46" name="TextBox 45"/>
+          <p:cNvSpPr txBox="1"/>
+          <p:nvPr/>
+        </p:nvSpPr>
+        <p:spPr>
+          <a:xfrm>
+            <a:off x="4636008" y="3995928"/>
+            <a:ext cx="1325880" cy="192024"/>
+          </a:xfrm>
+          <a:prstGeom prst="rect">
+            <a:avLst/>
+          </a:prstGeom>
+          <a:noFill/>
+        </p:spPr>
+        <p:txBody>
+          <a:bodyPr wrap="none" lIns="0" rIns="0" tIns="0" bIns="0" anchor="ctr">
+            <a:spAutoFit/>
+          </a:bodyPr>
+          <a:lstStyle/>
+          <a:p>
+            <a:pPr algn="l"/>
+            <a:r>
+              <a:rPr sz="850" b="0">
+                <a:solidFill>
+                  <a:srgbClr val="222B36"/>
+                </a:solidFill>
+                <a:latin typeface="Microsoft JhengHei"/>
+              </a:rPr>
+              <a:t>64.9%（538）</a:t>
+            </a:r>
+          </a:p>
+        </p:txBody>
+      </p:sp>
+      <p:sp>
+        <p:nvSpPr>
+          <p:cNvPr id="47" name="TextBox 46"/>
+          <p:cNvSpPr txBox="1"/>
+          <p:nvPr/>
+        </p:nvSpPr>
+        <p:spPr>
+          <a:xfrm>
+            <a:off x="4288536" y="4279392"/>
+            <a:ext cx="274320" cy="192024"/>
+          </a:xfrm>
+          <a:prstGeom prst="rect">
+            <a:avLst/>
+          </a:prstGeom>
+          <a:noFill/>
+        </p:spPr>
+        <p:txBody>
+          <a:bodyPr wrap="none" lIns="0" rIns="0" tIns="0" bIns="0" anchor="ctr">
+            <a:spAutoFit/>
+          </a:bodyPr>
+          <a:lstStyle/>
+          <a:p>
+            <a:pPr algn="l"/>
+            <a:r>
+              <a:rPr sz="850" b="1">
+                <a:solidFill>
+                  <a:srgbClr val="132338"/>
+                </a:solidFill>
+                <a:latin typeface="Microsoft JhengHei"/>
+              </a:rPr>
+              <a:t>5</a:t>
+            </a:r>
+          </a:p>
+        </p:txBody>
+      </p:sp>
+      <p:sp>
+        <p:nvSpPr>
+          <p:cNvPr id="48" name="TextBox 47"/>
+          <p:cNvSpPr txBox="1"/>
+          <p:nvPr/>
+        </p:nvSpPr>
+        <p:spPr>
+          <a:xfrm>
+            <a:off x="4636008" y="4279392"/>
+            <a:ext cx="1325880" cy="192024"/>
+          </a:xfrm>
+          <a:prstGeom prst="rect">
+            <a:avLst/>
+          </a:prstGeom>
+          <a:noFill/>
+        </p:spPr>
+        <p:txBody>
+          <a:bodyPr wrap="none" lIns="0" rIns="0" tIns="0" bIns="0" anchor="ctr">
+            <a:spAutoFit/>
+          </a:bodyPr>
+          <a:lstStyle/>
+          <a:p>
+            <a:pPr algn="l"/>
+            <a:r>
+              <a:rPr sz="850" b="0">
+                <a:solidFill>
+                  <a:srgbClr val="222B36"/>
+                </a:solidFill>
+                <a:latin typeface="Microsoft JhengHei"/>
+              </a:rPr>
+              <a:t>68.4%（19）</a:t>
+            </a:r>
+          </a:p>
+        </p:txBody>
+      </p:sp>
+      <p:sp>
+        <p:nvSpPr>
+          <p:cNvPr id="49" name="TextBox 48"/>
+          <p:cNvSpPr txBox="1"/>
+          <p:nvPr/>
+        </p:nvSpPr>
+        <p:spPr>
+          <a:xfrm>
+            <a:off x="4288536" y="4562856"/>
+            <a:ext cx="274320" cy="192024"/>
+          </a:xfrm>
+          <a:prstGeom prst="rect">
+            <a:avLst/>
+          </a:prstGeom>
+          <a:noFill/>
+        </p:spPr>
+        <p:txBody>
+          <a:bodyPr wrap="none" lIns="0" rIns="0" tIns="0" bIns="0" anchor="ctr">
+            <a:spAutoFit/>
+          </a:bodyPr>
+          <a:lstStyle/>
+          <a:p>
+            <a:pPr algn="l"/>
+            <a:r>
+              <a:rPr sz="850" b="1">
+                <a:solidFill>
+                  <a:srgbClr val="132338"/>
+                </a:solidFill>
+                <a:latin typeface="Microsoft JhengHei"/>
+              </a:rPr>
+              <a:t>6</a:t>
+            </a:r>
+          </a:p>
+        </p:txBody>
+      </p:sp>
+      <p:sp>
+        <p:nvSpPr>
+          <p:cNvPr id="50" name="TextBox 49"/>
+          <p:cNvSpPr txBox="1"/>
+          <p:nvPr/>
+        </p:nvSpPr>
+        <p:spPr>
+          <a:xfrm>
+            <a:off x="4636008" y="4562856"/>
+            <a:ext cx="1325880" cy="192024"/>
+          </a:xfrm>
+          <a:prstGeom prst="rect">
+            <a:avLst/>
+          </a:prstGeom>
+          <a:noFill/>
+        </p:spPr>
+        <p:txBody>
+          <a:bodyPr wrap="none" lIns="0" rIns="0" tIns="0" bIns="0" anchor="ctr">
+            <a:spAutoFit/>
+          </a:bodyPr>
+          <a:lstStyle/>
+          <a:p>
+            <a:pPr algn="l"/>
+            <a:r>
+              <a:rPr sz="850" b="0">
+                <a:solidFill>
+                  <a:srgbClr val="222B36"/>
+                </a:solidFill>
+                <a:latin typeface="Microsoft JhengHei"/>
+              </a:rPr>
+              <a:t>50.0%（4）</a:t>
+            </a:r>
+          </a:p>
+        </p:txBody>
+      </p:sp>
+      <p:sp>
+        <p:nvSpPr>
+          <p:cNvPr id="51" name="TextBox 50"/>
+          <p:cNvSpPr txBox="1"/>
+          <p:nvPr/>
+        </p:nvSpPr>
+        <p:spPr>
+          <a:xfrm>
+            <a:off x="4288536" y="4846320"/>
+            <a:ext cx="274320" cy="192024"/>
+          </a:xfrm>
+          <a:prstGeom prst="rect">
+            <a:avLst/>
+          </a:prstGeom>
+          <a:noFill/>
+        </p:spPr>
+        <p:txBody>
+          <a:bodyPr wrap="none" lIns="0" rIns="0" tIns="0" bIns="0" anchor="ctr">
+            <a:spAutoFit/>
+          </a:bodyPr>
+          <a:lstStyle/>
+          <a:p>
+            <a:pPr algn="l"/>
+            <a:r>
+              <a:rPr sz="850" b="1">
+                <a:solidFill>
+                  <a:srgbClr val="132338"/>
+                </a:solidFill>
+                <a:latin typeface="Microsoft JhengHei"/>
+              </a:rPr>
+              <a:t>7</a:t>
+            </a:r>
+          </a:p>
+        </p:txBody>
+      </p:sp>
+      <p:sp>
+        <p:nvSpPr>
+          <p:cNvPr id="52" name="TextBox 51"/>
+          <p:cNvSpPr txBox="1"/>
+          <p:nvPr/>
+        </p:nvSpPr>
+        <p:spPr>
+          <a:xfrm>
+            <a:off x="4636008" y="4846320"/>
+            <a:ext cx="1325880" cy="192024"/>
+          </a:xfrm>
+          <a:prstGeom prst="rect">
+            <a:avLst/>
+          </a:prstGeom>
+          <a:noFill/>
+        </p:spPr>
+        <p:txBody>
+          <a:bodyPr wrap="none" lIns="0" rIns="0" tIns="0" bIns="0" anchor="ctr">
+            <a:spAutoFit/>
+          </a:bodyPr>
+          <a:lstStyle/>
+          <a:p>
+            <a:pPr algn="l"/>
+            <a:r>
+              <a:rPr sz="850" b="0">
+                <a:solidFill>
+                  <a:srgbClr val="222B36"/>
+                </a:solidFill>
+                <a:latin typeface="Microsoft JhengHei"/>
+              </a:rPr>
+              <a:t>N/A（0）</a:t>
+            </a:r>
+          </a:p>
+        </p:txBody>
+      </p:sp>
+      <p:sp>
+        <p:nvSpPr>
+          <p:cNvPr id="53" name="TextBox 52"/>
+          <p:cNvSpPr txBox="1"/>
+          <p:nvPr/>
+        </p:nvSpPr>
+        <p:spPr>
+          <a:xfrm>
+            <a:off x="4270248" y="5230368"/>
+            <a:ext cx="2999232" cy="411480"/>
+          </a:xfrm>
+          <a:prstGeom prst="rect">
+            <a:avLst/>
+          </a:prstGeom>
+          <a:noFill/>
+        </p:spPr>
+        <p:txBody>
+          <a:bodyPr wrap="none" lIns="0" rIns="0" tIns="0" bIns="0" anchor="ctr">
+            <a:spAutoFit/>
+          </a:bodyPr>
+          <a:lstStyle/>
+          <a:p>
+            <a:pPr algn="l"/>
+            <a:r>
+              <a:rPr sz="760" b="0">
+                <a:solidFill>
+                  <a:srgbClr val="667280"/>
+                </a:solidFill>
+                <a:latin typeface="Microsoft JhengHei"/>
+              </a:rPr>
+              <a:t>選定參數｜n_estimators=200 · max_depth=12 · min_samples_leaf=1</a:t>
+            </a:r>
+          </a:p>
+        </p:txBody>
+      </p:sp>
+      <p:sp>
+        <p:nvSpPr>
+          <p:cNvPr id="54" name="TextBox 53"/>
+          <p:cNvSpPr txBox="1"/>
+          <p:nvPr/>
+        </p:nvSpPr>
+        <p:spPr>
+          <a:xfrm>
+            <a:off x="4270248" y="5614416"/>
+            <a:ext cx="2999232" cy="182880"/>
+          </a:xfrm>
+          <a:prstGeom prst="rect">
+            <a:avLst/>
+          </a:prstGeom>
+          <a:noFill/>
+        </p:spPr>
+        <p:txBody>
+          <a:bodyPr wrap="none" lIns="0" rIns="0" tIns="0" bIns="0" anchor="ctr">
+            <a:spAutoFit/>
+          </a:bodyPr>
+          <a:lstStyle/>
+          <a:p>
+            <a:pPr algn="l"/>
+            <a:r>
+              <a:rPr sz="720" b="0">
+                <a:solidFill>
+                  <a:srgbClr val="667280"/>
+                </a:solidFill>
+                <a:latin typeface="Microsoft JhengHei"/>
+              </a:rPr>
+              <a:t>驗證 Macro Recall 42.06% · Accuracy 45.83%</a:t>
+            </a:r>
+          </a:p>
+        </p:txBody>
+      </p:sp>
+      <p:sp>
+        <p:nvSpPr>
+          <p:cNvPr id="55" name="Rounded Rectangle 54"/>
           <p:cNvSpPr/>
           <p:nvPr/>
         </p:nvSpPr>
         <p:spPr>
           <a:xfrm>
-            <a:off x="3648456" y="1234440"/>
-            <a:ext cx="1325880" cy="850392"/>
+            <a:off x="7635240" y="1417320"/>
+            <a:ext cx="4050791" cy="4498848"/>
           </a:xfrm>
           <a:prstGeom prst="roundRect">
             <a:avLst/>
           </a:prstGeom>
           <a:solidFill>
-            <a:srgbClr val="FFFFFF"/>
+            <a:srgbClr val="132338"/>
           </a:solidFill>
           <a:ln>
             <a:solidFill>
-              <a:srgbClr val="E2E7E6"/>
+              <a:srgbClr val="132338"/>
             </a:solidFill>
           </a:ln>
         </p:spPr>
@@ -3566,20 +5023,19 @@
           <a:lstStyle/>
           <a:p>
             <a:pPr algn="ctr"/>
-            <a:endParaRPr/>
-          </a:p>
-        </p:txBody>
-      </p:sp>
-      <p:sp>
-        <p:nvSpPr>
-          <p:cNvPr id="14" name="TextBox 13"/>
+          </a:p>
+        </p:txBody>
+      </p:sp>
+      <p:sp>
+        <p:nvSpPr>
+          <p:cNvPr id="56" name="TextBox 55"/>
           <p:cNvSpPr txBox="1"/>
           <p:nvPr/>
         </p:nvSpPr>
         <p:spPr>
           <a:xfrm>
-            <a:off x="3813048" y="1325880"/>
-            <a:ext cx="996695" cy="201168"/>
+            <a:off x="7918704" y="1664208"/>
+            <a:ext cx="3474720" cy="502920"/>
           </a:xfrm>
           <a:prstGeom prst="rect">
             <a:avLst/>
@@ -3587,34 +5043,34 @@
           <a:noFill/>
         </p:spPr>
         <p:txBody>
-          <a:bodyPr wrap="none" lIns="0" tIns="0" rIns="0" bIns="0" anchor="ctr">
+          <a:bodyPr wrap="none" lIns="0" rIns="0" tIns="0" bIns="0" anchor="ctr">
             <a:spAutoFit/>
           </a:bodyPr>
           <a:lstStyle/>
           <a:p>
             <a:pPr algn="l"/>
             <a:r>
-              <a:rPr sz="900" b="0">
-                <a:solidFill>
-                  <a:srgbClr val="667280"/>
+              <a:rPr sz="1300" b="1">
+                <a:solidFill>
+                  <a:srgbClr val="FFFFFF"/>
                 </a:solidFill>
                 <a:latin typeface="Microsoft JhengHei"/>
               </a:rPr>
-              <a:t>測試資料</a:t>
-            </a:r>
-          </a:p>
-        </p:txBody>
-      </p:sp>
-      <p:sp>
-        <p:nvSpPr>
-          <p:cNvPr id="15" name="TextBox 14"/>
+              <a:t>比較結論｜隨機森林在時間外推測試的 Macro Recall 優先領先，且 Accuracy 亦領先。</a:t>
+            </a:r>
+          </a:p>
+        </p:txBody>
+      </p:sp>
+      <p:sp>
+        <p:nvSpPr>
+          <p:cNvPr id="57" name="TextBox 56"/>
           <p:cNvSpPr txBox="1"/>
           <p:nvPr/>
         </p:nvSpPr>
         <p:spPr>
           <a:xfrm>
-            <a:off x="3813048" y="1517904"/>
-            <a:ext cx="996695" cy="310896"/>
+            <a:off x="7918704" y="2404872"/>
+            <a:ext cx="3456432" cy="594360"/>
           </a:xfrm>
           <a:prstGeom prst="rect">
             <a:avLst/>
@@ -3622,34 +5078,34 @@
           <a:noFill/>
         </p:spPr>
         <p:txBody>
-          <a:bodyPr wrap="none" lIns="0" tIns="0" rIns="0" bIns="0" anchor="ctr">
+          <a:bodyPr wrap="none" lIns="0" rIns="0" tIns="0" bIns="0" anchor="ctr">
             <a:spAutoFit/>
           </a:bodyPr>
           <a:lstStyle/>
           <a:p>
             <a:pPr algn="l"/>
             <a:r>
-              <a:rPr sz="1800" b="1">
-                <a:solidFill>
-                  <a:srgbClr val="222B36"/>
+              <a:rPr sz="1000" b="0">
+                <a:solidFill>
+                  <a:srgbClr val="FFFFFF"/>
                 </a:solidFill>
                 <a:latin typeface="Microsoft JhengHei"/>
               </a:rPr>
-              <a:t>3,039</a:t>
-            </a:r>
-          </a:p>
-        </p:txBody>
-      </p:sp>
-      <p:sp>
-        <p:nvSpPr>
-          <p:cNvPr id="16" name="TextBox 15"/>
+              <a:t>決策樹｜Macro Recall 30.43%｜Accuracy 28.33%</a:t>
+            </a:r>
+          </a:p>
+        </p:txBody>
+      </p:sp>
+      <p:sp>
+        <p:nvSpPr>
+          <p:cNvPr id="58" name="TextBox 57"/>
           <p:cNvSpPr txBox="1"/>
           <p:nvPr/>
         </p:nvSpPr>
         <p:spPr>
           <a:xfrm>
-            <a:off x="3813048" y="1847088"/>
-            <a:ext cx="996695" cy="146304"/>
+            <a:off x="7918704" y="3044952"/>
+            <a:ext cx="3456432" cy="594360"/>
           </a:xfrm>
           <a:prstGeom prst="rect">
             <a:avLst/>
@@ -3657,34 +5113,34 @@
           <a:noFill/>
         </p:spPr>
         <p:txBody>
-          <a:bodyPr wrap="none" lIns="0" tIns="0" rIns="0" bIns="0" anchor="ctr">
+          <a:bodyPr wrap="none" lIns="0" rIns="0" tIns="0" bIns="0" anchor="ctr">
             <a:spAutoFit/>
           </a:bodyPr>
           <a:lstStyle/>
           <a:p>
             <a:pPr algn="l"/>
             <a:r>
-              <a:rPr sz="750" b="0">
-                <a:solidFill>
-                  <a:srgbClr val="667280"/>
+              <a:rPr sz="1000" b="0">
+                <a:solidFill>
+                  <a:srgbClr val="FFFFFF"/>
                 </a:solidFill>
                 <a:latin typeface="Microsoft JhengHei"/>
               </a:rPr>
-              <a:t>2024–2026</a:t>
-            </a:r>
-          </a:p>
-        </p:txBody>
-      </p:sp>
-      <p:sp>
-        <p:nvSpPr>
-          <p:cNvPr id="17" name="TextBox 16"/>
+              <a:t>隨機森林｜Macro Recall 40.81%｜Accuracy 43.90%</a:t>
+            </a:r>
+          </a:p>
+        </p:txBody>
+      </p:sp>
+      <p:sp>
+        <p:nvSpPr>
+          <p:cNvPr id="59" name="TextBox 58"/>
           <p:cNvSpPr txBox="1"/>
           <p:nvPr/>
         </p:nvSpPr>
         <p:spPr>
           <a:xfrm>
-            <a:off x="521207" y="2304288"/>
-            <a:ext cx="4206240" cy="256032"/>
+            <a:off x="7918704" y="3977639"/>
+            <a:ext cx="3429000" cy="1234440"/>
           </a:xfrm>
           <a:prstGeom prst="rect">
             <a:avLst/>
@@ -3692,34 +5148,34 @@
           <a:noFill/>
         </p:spPr>
         <p:txBody>
-          <a:bodyPr wrap="none" lIns="0" tIns="0" rIns="0" bIns="0" anchor="ctr">
+          <a:bodyPr wrap="none" lIns="0" rIns="0" tIns="0" bIns="0" anchor="ctr">
             <a:spAutoFit/>
           </a:bodyPr>
           <a:lstStyle/>
           <a:p>
             <a:pPr algn="l"/>
             <a:r>
-              <a:rPr sz="1300" b="1">
-                <a:solidFill>
-                  <a:srgbClr val="132338"/>
+              <a:rPr sz="1100" b="1">
+                <a:solidFill>
+                  <a:srgbClr val="FFFFFF"/>
                 </a:solidFill>
                 <a:latin typeface="Microsoft JhengHei"/>
               </a:rPr>
-              <a:t>各震度命中率（Recall）</a:t>
-            </a:r>
-          </a:p>
-        </p:txBody>
-      </p:sp>
-      <p:sp>
-        <p:nvSpPr>
-          <p:cNvPr id="18" name="TextBox 17"/>
+              <a:t>稀有類別限制｜測試集震度 0 僅 1 筆、震度 6 僅 4 筆、震度 7 為 0 筆；其 Recall 不宜視為穩定結論。</a:t>
+            </a:r>
+          </a:p>
+        </p:txBody>
+      </p:sp>
+      <p:sp>
+        <p:nvSpPr>
+          <p:cNvPr id="60" name="TextBox 59"/>
           <p:cNvSpPr txBox="1"/>
           <p:nvPr/>
         </p:nvSpPr>
         <p:spPr>
           <a:xfrm>
-            <a:off x="521207" y="2578608"/>
-            <a:ext cx="4206240" cy="182880"/>
+            <a:off x="530352" y="6208776"/>
+            <a:ext cx="11064240" cy="283464"/>
           </a:xfrm>
           <a:prstGeom prst="rect">
             <a:avLst/>
@@ -3727,1543 +5183,20 @@
           <a:noFill/>
         </p:spPr>
         <p:txBody>
-          <a:bodyPr wrap="none" lIns="0" tIns="0" rIns="0" bIns="0" anchor="ctr">
+          <a:bodyPr wrap="none" lIns="0" rIns="0" tIns="0" bIns="0" anchor="ctr">
             <a:spAutoFit/>
           </a:bodyPr>
           <a:lstStyle/>
           <a:p>
             <a:pPr algn="l"/>
             <a:r>
-              <a:rPr sz="850" b="0">
+              <a:rPr sz="900" b="0">
                 <a:solidFill>
                   <a:srgbClr val="667280"/>
                 </a:solidFill>
                 <a:latin typeface="Microsoft JhengHei"/>
               </a:rPr>
-              <a:t>百分比旁括號為測試樣本數</a:t>
-            </a:r>
-          </a:p>
-        </p:txBody>
-      </p:sp>
-      <p:sp>
-        <p:nvSpPr>
-          <p:cNvPr id="19" name="TextBox 18"/>
-          <p:cNvSpPr txBox="1"/>
-          <p:nvPr/>
-        </p:nvSpPr>
-        <p:spPr>
-          <a:xfrm>
-            <a:off x="530352" y="2834640"/>
-            <a:ext cx="292608" cy="201168"/>
-          </a:xfrm>
-          <a:prstGeom prst="rect">
-            <a:avLst/>
-          </a:prstGeom>
-          <a:noFill/>
-        </p:spPr>
-        <p:txBody>
-          <a:bodyPr wrap="none" lIns="0" tIns="0" rIns="0" bIns="0" anchor="ctr">
-            <a:spAutoFit/>
-          </a:bodyPr>
-          <a:lstStyle/>
-          <a:p>
-            <a:pPr algn="l"/>
-            <a:r>
-              <a:rPr sz="950" b="1">
-                <a:solidFill>
-                  <a:srgbClr val="132338"/>
-                </a:solidFill>
-                <a:latin typeface="Microsoft JhengHei"/>
-              </a:rPr>
-              <a:t>0</a:t>
-            </a:r>
-          </a:p>
-        </p:txBody>
-      </p:sp>
-      <p:sp>
-        <p:nvSpPr>
-          <p:cNvPr id="20" name="Rectangle 19"/>
-          <p:cNvSpPr/>
-          <p:nvPr/>
-        </p:nvSpPr>
-        <p:spPr>
-          <a:xfrm>
-            <a:off x="877824" y="2852928"/>
-            <a:ext cx="2240280" cy="146304"/>
-          </a:xfrm>
-          <a:prstGeom prst="rect">
-            <a:avLst/>
-          </a:prstGeom>
-          <a:solidFill>
-            <a:srgbClr val="E2E7E6"/>
-          </a:solidFill>
-          <a:ln>
-            <a:solidFill>
-              <a:srgbClr val="E2E7E6"/>
-            </a:solidFill>
-          </a:ln>
-        </p:spPr>
-        <p:style>
-          <a:lnRef idx="1">
-            <a:schemeClr val="accent1"/>
-          </a:lnRef>
-          <a:fillRef idx="3">
-            <a:schemeClr val="accent1"/>
-          </a:fillRef>
-          <a:effectRef idx="2">
-            <a:schemeClr val="accent1"/>
-          </a:effectRef>
-          <a:fontRef idx="minor">
-            <a:schemeClr val="lt1"/>
-          </a:fontRef>
-        </p:style>
-        <p:txBody>
-          <a:bodyPr rtlCol="0" anchor="ctr"/>
-          <a:lstStyle/>
-          <a:p>
-            <a:pPr algn="ctr"/>
-            <a:endParaRPr/>
-          </a:p>
-        </p:txBody>
-      </p:sp>
-      <p:sp>
-        <p:nvSpPr>
-          <p:cNvPr id="21" name="TextBox 20"/>
-          <p:cNvSpPr txBox="1"/>
-          <p:nvPr/>
-        </p:nvSpPr>
-        <p:spPr>
-          <a:xfrm>
-            <a:off x="3227832" y="2825496"/>
-            <a:ext cx="1417320" cy="219456"/>
-          </a:xfrm>
-          <a:prstGeom prst="rect">
-            <a:avLst/>
-          </a:prstGeom>
-          <a:noFill/>
-        </p:spPr>
-        <p:txBody>
-          <a:bodyPr wrap="none" lIns="0" tIns="0" rIns="0" bIns="0" anchor="ctr">
-            <a:spAutoFit/>
-          </a:bodyPr>
-          <a:lstStyle/>
-          <a:p>
-            <a:pPr algn="l"/>
-            <a:r>
-              <a:rPr sz="850" b="0">
-                <a:solidFill>
-                  <a:srgbClr val="222B36"/>
-                </a:solidFill>
-                <a:latin typeface="Microsoft JhengHei"/>
-              </a:rPr>
-              <a:t>0.0%  (1)</a:t>
-            </a:r>
-          </a:p>
-        </p:txBody>
-      </p:sp>
-      <p:sp>
-        <p:nvSpPr>
-          <p:cNvPr id="22" name="TextBox 21"/>
-          <p:cNvSpPr txBox="1"/>
-          <p:nvPr/>
-        </p:nvSpPr>
-        <p:spPr>
-          <a:xfrm>
-            <a:off x="530352" y="3191256"/>
-            <a:ext cx="292608" cy="201168"/>
-          </a:xfrm>
-          <a:prstGeom prst="rect">
-            <a:avLst/>
-          </a:prstGeom>
-          <a:noFill/>
-        </p:spPr>
-        <p:txBody>
-          <a:bodyPr wrap="none" lIns="0" tIns="0" rIns="0" bIns="0" anchor="ctr">
-            <a:spAutoFit/>
-          </a:bodyPr>
-          <a:lstStyle/>
-          <a:p>
-            <a:pPr algn="l"/>
-            <a:r>
-              <a:rPr sz="950" b="1">
-                <a:solidFill>
-                  <a:srgbClr val="132338"/>
-                </a:solidFill>
-                <a:latin typeface="Microsoft JhengHei"/>
-              </a:rPr>
-              <a:t>1</a:t>
-            </a:r>
-          </a:p>
-        </p:txBody>
-      </p:sp>
-      <p:sp>
-        <p:nvSpPr>
-          <p:cNvPr id="23" name="Rectangle 22"/>
-          <p:cNvSpPr/>
-          <p:nvPr/>
-        </p:nvSpPr>
-        <p:spPr>
-          <a:xfrm>
-            <a:off x="877824" y="3209544"/>
-            <a:ext cx="2240280" cy="146304"/>
-          </a:xfrm>
-          <a:prstGeom prst="rect">
-            <a:avLst/>
-          </a:prstGeom>
-          <a:solidFill>
-            <a:srgbClr val="E2E7E6"/>
-          </a:solidFill>
-          <a:ln>
-            <a:solidFill>
-              <a:srgbClr val="E2E7E6"/>
-            </a:solidFill>
-          </a:ln>
-        </p:spPr>
-        <p:style>
-          <a:lnRef idx="1">
-            <a:schemeClr val="accent1"/>
-          </a:lnRef>
-          <a:fillRef idx="3">
-            <a:schemeClr val="accent1"/>
-          </a:fillRef>
-          <a:effectRef idx="2">
-            <a:schemeClr val="accent1"/>
-          </a:effectRef>
-          <a:fontRef idx="minor">
-            <a:schemeClr val="lt1"/>
-          </a:fontRef>
-        </p:style>
-        <p:txBody>
-          <a:bodyPr rtlCol="0" anchor="ctr"/>
-          <a:lstStyle/>
-          <a:p>
-            <a:pPr algn="ctr"/>
-            <a:endParaRPr/>
-          </a:p>
-        </p:txBody>
-      </p:sp>
-      <p:sp>
-        <p:nvSpPr>
-          <p:cNvPr id="24" name="Rectangle 23"/>
-          <p:cNvSpPr/>
-          <p:nvPr/>
-        </p:nvSpPr>
-        <p:spPr>
-          <a:xfrm>
-            <a:off x="877824" y="3209544"/>
-            <a:ext cx="589139" cy="146304"/>
-          </a:xfrm>
-          <a:prstGeom prst="rect">
-            <a:avLst/>
-          </a:prstGeom>
-          <a:solidFill>
-            <a:srgbClr val="1F807D"/>
-          </a:solidFill>
-          <a:ln>
-            <a:solidFill>
-              <a:srgbClr val="1F807D"/>
-            </a:solidFill>
-          </a:ln>
-        </p:spPr>
-        <p:style>
-          <a:lnRef idx="1">
-            <a:schemeClr val="accent1"/>
-          </a:lnRef>
-          <a:fillRef idx="3">
-            <a:schemeClr val="accent1"/>
-          </a:fillRef>
-          <a:effectRef idx="2">
-            <a:schemeClr val="accent1"/>
-          </a:effectRef>
-          <a:fontRef idx="minor">
-            <a:schemeClr val="lt1"/>
-          </a:fontRef>
-        </p:style>
-        <p:txBody>
-          <a:bodyPr rtlCol="0" anchor="ctr"/>
-          <a:lstStyle/>
-          <a:p>
-            <a:pPr algn="ctr"/>
-            <a:endParaRPr/>
-          </a:p>
-        </p:txBody>
-      </p:sp>
-      <p:sp>
-        <p:nvSpPr>
-          <p:cNvPr id="25" name="TextBox 24"/>
-          <p:cNvSpPr txBox="1"/>
-          <p:nvPr/>
-        </p:nvSpPr>
-        <p:spPr>
-          <a:xfrm>
-            <a:off x="3227832" y="3182112"/>
-            <a:ext cx="1417320" cy="219456"/>
-          </a:xfrm>
-          <a:prstGeom prst="rect">
-            <a:avLst/>
-          </a:prstGeom>
-          <a:noFill/>
-        </p:spPr>
-        <p:txBody>
-          <a:bodyPr wrap="none" lIns="0" tIns="0" rIns="0" bIns="0" anchor="ctr">
-            <a:spAutoFit/>
-          </a:bodyPr>
-          <a:lstStyle/>
-          <a:p>
-            <a:pPr algn="l"/>
-            <a:r>
-              <a:rPr sz="850" b="0">
-                <a:solidFill>
-                  <a:srgbClr val="222B36"/>
-                </a:solidFill>
-                <a:latin typeface="Microsoft JhengHei"/>
-              </a:rPr>
-              <a:t>26.3%  (289)</a:t>
-            </a:r>
-          </a:p>
-        </p:txBody>
-      </p:sp>
-      <p:sp>
-        <p:nvSpPr>
-          <p:cNvPr id="26" name="TextBox 25"/>
-          <p:cNvSpPr txBox="1"/>
-          <p:nvPr/>
-        </p:nvSpPr>
-        <p:spPr>
-          <a:xfrm>
-            <a:off x="530352" y="3547872"/>
-            <a:ext cx="292608" cy="201168"/>
-          </a:xfrm>
-          <a:prstGeom prst="rect">
-            <a:avLst/>
-          </a:prstGeom>
-          <a:noFill/>
-        </p:spPr>
-        <p:txBody>
-          <a:bodyPr wrap="none" lIns="0" tIns="0" rIns="0" bIns="0" anchor="ctr">
-            <a:spAutoFit/>
-          </a:bodyPr>
-          <a:lstStyle/>
-          <a:p>
-            <a:pPr algn="l"/>
-            <a:r>
-              <a:rPr sz="950" b="1">
-                <a:solidFill>
-                  <a:srgbClr val="132338"/>
-                </a:solidFill>
-                <a:latin typeface="Microsoft JhengHei"/>
-              </a:rPr>
-              <a:t>2</a:t>
-            </a:r>
-          </a:p>
-        </p:txBody>
-      </p:sp>
-      <p:sp>
-        <p:nvSpPr>
-          <p:cNvPr id="27" name="Rectangle 26"/>
-          <p:cNvSpPr/>
-          <p:nvPr/>
-        </p:nvSpPr>
-        <p:spPr>
-          <a:xfrm>
-            <a:off x="877824" y="3566160"/>
-            <a:ext cx="2240280" cy="146304"/>
-          </a:xfrm>
-          <a:prstGeom prst="rect">
-            <a:avLst/>
-          </a:prstGeom>
-          <a:solidFill>
-            <a:srgbClr val="E2E7E6"/>
-          </a:solidFill>
-          <a:ln>
-            <a:solidFill>
-              <a:srgbClr val="E2E7E6"/>
-            </a:solidFill>
-          </a:ln>
-        </p:spPr>
-        <p:style>
-          <a:lnRef idx="1">
-            <a:schemeClr val="accent1"/>
-          </a:lnRef>
-          <a:fillRef idx="3">
-            <a:schemeClr val="accent1"/>
-          </a:fillRef>
-          <a:effectRef idx="2">
-            <a:schemeClr val="accent1"/>
-          </a:effectRef>
-          <a:fontRef idx="minor">
-            <a:schemeClr val="lt1"/>
-          </a:fontRef>
-        </p:style>
-        <p:txBody>
-          <a:bodyPr rtlCol="0" anchor="ctr"/>
-          <a:lstStyle/>
-          <a:p>
-            <a:pPr algn="ctr"/>
-            <a:endParaRPr/>
-          </a:p>
-        </p:txBody>
-      </p:sp>
-      <p:sp>
-        <p:nvSpPr>
-          <p:cNvPr id="28" name="Rectangle 27"/>
-          <p:cNvSpPr/>
-          <p:nvPr/>
-        </p:nvSpPr>
-        <p:spPr>
-          <a:xfrm>
-            <a:off x="877824" y="3566160"/>
-            <a:ext cx="566205" cy="146304"/>
-          </a:xfrm>
-          <a:prstGeom prst="rect">
-            <a:avLst/>
-          </a:prstGeom>
-          <a:solidFill>
-            <a:srgbClr val="1F807D"/>
-          </a:solidFill>
-          <a:ln>
-            <a:solidFill>
-              <a:srgbClr val="1F807D"/>
-            </a:solidFill>
-          </a:ln>
-        </p:spPr>
-        <p:style>
-          <a:lnRef idx="1">
-            <a:schemeClr val="accent1"/>
-          </a:lnRef>
-          <a:fillRef idx="3">
-            <a:schemeClr val="accent1"/>
-          </a:fillRef>
-          <a:effectRef idx="2">
-            <a:schemeClr val="accent1"/>
-          </a:effectRef>
-          <a:fontRef idx="minor">
-            <a:schemeClr val="lt1"/>
-          </a:fontRef>
-        </p:style>
-        <p:txBody>
-          <a:bodyPr rtlCol="0" anchor="ctr"/>
-          <a:lstStyle/>
-          <a:p>
-            <a:pPr algn="ctr"/>
-            <a:endParaRPr/>
-          </a:p>
-        </p:txBody>
-      </p:sp>
-      <p:sp>
-        <p:nvSpPr>
-          <p:cNvPr id="29" name="TextBox 28"/>
-          <p:cNvSpPr txBox="1"/>
-          <p:nvPr/>
-        </p:nvSpPr>
-        <p:spPr>
-          <a:xfrm>
-            <a:off x="3227832" y="3538728"/>
-            <a:ext cx="1417320" cy="219456"/>
-          </a:xfrm>
-          <a:prstGeom prst="rect">
-            <a:avLst/>
-          </a:prstGeom>
-          <a:noFill/>
-        </p:spPr>
-        <p:txBody>
-          <a:bodyPr wrap="none" lIns="0" tIns="0" rIns="0" bIns="0" anchor="ctr">
-            <a:spAutoFit/>
-          </a:bodyPr>
-          <a:lstStyle/>
-          <a:p>
-            <a:pPr algn="l"/>
-            <a:r>
-              <a:rPr sz="850" b="0">
-                <a:solidFill>
-                  <a:srgbClr val="222B36"/>
-                </a:solidFill>
-                <a:latin typeface="Microsoft JhengHei"/>
-              </a:rPr>
-              <a:t>25.3%  (1,278)</a:t>
-            </a:r>
-          </a:p>
-        </p:txBody>
-      </p:sp>
-      <p:sp>
-        <p:nvSpPr>
-          <p:cNvPr id="30" name="TextBox 29"/>
-          <p:cNvSpPr txBox="1"/>
-          <p:nvPr/>
-        </p:nvSpPr>
-        <p:spPr>
-          <a:xfrm>
-            <a:off x="530352" y="3904487"/>
-            <a:ext cx="292608" cy="201168"/>
-          </a:xfrm>
-          <a:prstGeom prst="rect">
-            <a:avLst/>
-          </a:prstGeom>
-          <a:noFill/>
-        </p:spPr>
-        <p:txBody>
-          <a:bodyPr wrap="none" lIns="0" tIns="0" rIns="0" bIns="0" anchor="ctr">
-            <a:spAutoFit/>
-          </a:bodyPr>
-          <a:lstStyle/>
-          <a:p>
-            <a:pPr algn="l"/>
-            <a:r>
-              <a:rPr sz="950" b="1">
-                <a:solidFill>
-                  <a:srgbClr val="132338"/>
-                </a:solidFill>
-                <a:latin typeface="Microsoft JhengHei"/>
-              </a:rPr>
-              <a:t>3</a:t>
-            </a:r>
-          </a:p>
-        </p:txBody>
-      </p:sp>
-      <p:sp>
-        <p:nvSpPr>
-          <p:cNvPr id="31" name="Rectangle 30"/>
-          <p:cNvSpPr/>
-          <p:nvPr/>
-        </p:nvSpPr>
-        <p:spPr>
-          <a:xfrm>
-            <a:off x="877824" y="3922775"/>
-            <a:ext cx="2240280" cy="146304"/>
-          </a:xfrm>
-          <a:prstGeom prst="rect">
-            <a:avLst/>
-          </a:prstGeom>
-          <a:solidFill>
-            <a:srgbClr val="E2E7E6"/>
-          </a:solidFill>
-          <a:ln>
-            <a:solidFill>
-              <a:srgbClr val="E2E7E6"/>
-            </a:solidFill>
-          </a:ln>
-        </p:spPr>
-        <p:style>
-          <a:lnRef idx="1">
-            <a:schemeClr val="accent1"/>
-          </a:lnRef>
-          <a:fillRef idx="3">
-            <a:schemeClr val="accent1"/>
-          </a:fillRef>
-          <a:effectRef idx="2">
-            <a:schemeClr val="accent1"/>
-          </a:effectRef>
-          <a:fontRef idx="minor">
-            <a:schemeClr val="lt1"/>
-          </a:fontRef>
-        </p:style>
-        <p:txBody>
-          <a:bodyPr rtlCol="0" anchor="ctr"/>
-          <a:lstStyle/>
-          <a:p>
-            <a:pPr algn="ctr"/>
-            <a:endParaRPr/>
-          </a:p>
-        </p:txBody>
-      </p:sp>
-      <p:sp>
-        <p:nvSpPr>
-          <p:cNvPr id="32" name="Rectangle 31"/>
-          <p:cNvSpPr/>
-          <p:nvPr/>
-        </p:nvSpPr>
-        <p:spPr>
-          <a:xfrm>
-            <a:off x="877824" y="3922775"/>
-            <a:ext cx="640080" cy="146304"/>
-          </a:xfrm>
-          <a:prstGeom prst="rect">
-            <a:avLst/>
-          </a:prstGeom>
-          <a:solidFill>
-            <a:srgbClr val="1F807D"/>
-          </a:solidFill>
-          <a:ln>
-            <a:solidFill>
-              <a:srgbClr val="1F807D"/>
-            </a:solidFill>
-          </a:ln>
-        </p:spPr>
-        <p:style>
-          <a:lnRef idx="1">
-            <a:schemeClr val="accent1"/>
-          </a:lnRef>
-          <a:fillRef idx="3">
-            <a:schemeClr val="accent1"/>
-          </a:fillRef>
-          <a:effectRef idx="2">
-            <a:schemeClr val="accent1"/>
-          </a:effectRef>
-          <a:fontRef idx="minor">
-            <a:schemeClr val="lt1"/>
-          </a:fontRef>
-        </p:style>
-        <p:txBody>
-          <a:bodyPr rtlCol="0" anchor="ctr"/>
-          <a:lstStyle/>
-          <a:p>
-            <a:pPr algn="ctr"/>
-            <a:endParaRPr/>
-          </a:p>
-        </p:txBody>
-      </p:sp>
-      <p:sp>
-        <p:nvSpPr>
-          <p:cNvPr id="33" name="TextBox 32"/>
-          <p:cNvSpPr txBox="1"/>
-          <p:nvPr/>
-        </p:nvSpPr>
-        <p:spPr>
-          <a:xfrm>
-            <a:off x="3227832" y="3895344"/>
-            <a:ext cx="1417320" cy="219456"/>
-          </a:xfrm>
-          <a:prstGeom prst="rect">
-            <a:avLst/>
-          </a:prstGeom>
-          <a:noFill/>
-        </p:spPr>
-        <p:txBody>
-          <a:bodyPr wrap="none" lIns="0" tIns="0" rIns="0" bIns="0" anchor="ctr">
-            <a:spAutoFit/>
-          </a:bodyPr>
-          <a:lstStyle/>
-          <a:p>
-            <a:pPr algn="l"/>
-            <a:r>
-              <a:rPr sz="850" b="0">
-                <a:solidFill>
-                  <a:srgbClr val="222B36"/>
-                </a:solidFill>
-                <a:latin typeface="Microsoft JhengHei"/>
-              </a:rPr>
-              <a:t>28.6%  (910)</a:t>
-            </a:r>
-          </a:p>
-        </p:txBody>
-      </p:sp>
-      <p:sp>
-        <p:nvSpPr>
-          <p:cNvPr id="34" name="TextBox 33"/>
-          <p:cNvSpPr txBox="1"/>
-          <p:nvPr/>
-        </p:nvSpPr>
-        <p:spPr>
-          <a:xfrm>
-            <a:off x="530352" y="4261104"/>
-            <a:ext cx="292608" cy="201168"/>
-          </a:xfrm>
-          <a:prstGeom prst="rect">
-            <a:avLst/>
-          </a:prstGeom>
-          <a:noFill/>
-        </p:spPr>
-        <p:txBody>
-          <a:bodyPr wrap="none" lIns="0" tIns="0" rIns="0" bIns="0" anchor="ctr">
-            <a:spAutoFit/>
-          </a:bodyPr>
-          <a:lstStyle/>
-          <a:p>
-            <a:pPr algn="l"/>
-            <a:r>
-              <a:rPr sz="950" b="1">
-                <a:solidFill>
-                  <a:srgbClr val="132338"/>
-                </a:solidFill>
-                <a:latin typeface="Microsoft JhengHei"/>
-              </a:rPr>
-              <a:t>4</a:t>
-            </a:r>
-          </a:p>
-        </p:txBody>
-      </p:sp>
-      <p:sp>
-        <p:nvSpPr>
-          <p:cNvPr id="35" name="Rectangle 34"/>
-          <p:cNvSpPr/>
-          <p:nvPr/>
-        </p:nvSpPr>
-        <p:spPr>
-          <a:xfrm>
-            <a:off x="877824" y="4279392"/>
-            <a:ext cx="2240280" cy="146304"/>
-          </a:xfrm>
-          <a:prstGeom prst="rect">
-            <a:avLst/>
-          </a:prstGeom>
-          <a:solidFill>
-            <a:srgbClr val="E2E7E6"/>
-          </a:solidFill>
-          <a:ln>
-            <a:solidFill>
-              <a:srgbClr val="E2E7E6"/>
-            </a:solidFill>
-          </a:ln>
-        </p:spPr>
-        <p:style>
-          <a:lnRef idx="1">
-            <a:schemeClr val="accent1"/>
-          </a:lnRef>
-          <a:fillRef idx="3">
-            <a:schemeClr val="accent1"/>
-          </a:fillRef>
-          <a:effectRef idx="2">
-            <a:schemeClr val="accent1"/>
-          </a:effectRef>
-          <a:fontRef idx="minor">
-            <a:schemeClr val="lt1"/>
-          </a:fontRef>
-        </p:style>
-        <p:txBody>
-          <a:bodyPr rtlCol="0" anchor="ctr"/>
-          <a:lstStyle/>
-          <a:p>
-            <a:pPr algn="ctr"/>
-            <a:endParaRPr/>
-          </a:p>
-        </p:txBody>
-      </p:sp>
-      <p:sp>
-        <p:nvSpPr>
-          <p:cNvPr id="36" name="Rectangle 35"/>
-          <p:cNvSpPr/>
-          <p:nvPr/>
-        </p:nvSpPr>
-        <p:spPr>
-          <a:xfrm>
-            <a:off x="877824" y="4279392"/>
-            <a:ext cx="795341" cy="146304"/>
-          </a:xfrm>
-          <a:prstGeom prst="rect">
-            <a:avLst/>
-          </a:prstGeom>
-          <a:solidFill>
-            <a:srgbClr val="1F807D"/>
-          </a:solidFill>
-          <a:ln>
-            <a:solidFill>
-              <a:srgbClr val="1F807D"/>
-            </a:solidFill>
-          </a:ln>
-        </p:spPr>
-        <p:style>
-          <a:lnRef idx="1">
-            <a:schemeClr val="accent1"/>
-          </a:lnRef>
-          <a:fillRef idx="3">
-            <a:schemeClr val="accent1"/>
-          </a:fillRef>
-          <a:effectRef idx="2">
-            <a:schemeClr val="accent1"/>
-          </a:effectRef>
-          <a:fontRef idx="minor">
-            <a:schemeClr val="lt1"/>
-          </a:fontRef>
-        </p:style>
-        <p:txBody>
-          <a:bodyPr rtlCol="0" anchor="ctr"/>
-          <a:lstStyle/>
-          <a:p>
-            <a:pPr algn="ctr"/>
-            <a:endParaRPr/>
-          </a:p>
-        </p:txBody>
-      </p:sp>
-      <p:sp>
-        <p:nvSpPr>
-          <p:cNvPr id="37" name="TextBox 36"/>
-          <p:cNvSpPr txBox="1"/>
-          <p:nvPr/>
-        </p:nvSpPr>
-        <p:spPr>
-          <a:xfrm>
-            <a:off x="3227832" y="4251960"/>
-            <a:ext cx="1417320" cy="219456"/>
-          </a:xfrm>
-          <a:prstGeom prst="rect">
-            <a:avLst/>
-          </a:prstGeom>
-          <a:noFill/>
-        </p:spPr>
-        <p:txBody>
-          <a:bodyPr wrap="none" lIns="0" tIns="0" rIns="0" bIns="0" anchor="ctr">
-            <a:spAutoFit/>
-          </a:bodyPr>
-          <a:lstStyle/>
-          <a:p>
-            <a:pPr algn="l"/>
-            <a:r>
-              <a:rPr sz="850" b="0">
-                <a:solidFill>
-                  <a:srgbClr val="222B36"/>
-                </a:solidFill>
-                <a:latin typeface="Microsoft JhengHei"/>
-              </a:rPr>
-              <a:t>35.5%  (538)</a:t>
-            </a:r>
-          </a:p>
-        </p:txBody>
-      </p:sp>
-      <p:sp>
-        <p:nvSpPr>
-          <p:cNvPr id="38" name="TextBox 37"/>
-          <p:cNvSpPr txBox="1"/>
-          <p:nvPr/>
-        </p:nvSpPr>
-        <p:spPr>
-          <a:xfrm>
-            <a:off x="530352" y="4617720"/>
-            <a:ext cx="292608" cy="201168"/>
-          </a:xfrm>
-          <a:prstGeom prst="rect">
-            <a:avLst/>
-          </a:prstGeom>
-          <a:noFill/>
-        </p:spPr>
-        <p:txBody>
-          <a:bodyPr wrap="none" lIns="0" tIns="0" rIns="0" bIns="0" anchor="ctr">
-            <a:spAutoFit/>
-          </a:bodyPr>
-          <a:lstStyle/>
-          <a:p>
-            <a:pPr algn="l"/>
-            <a:r>
-              <a:rPr sz="950" b="1">
-                <a:solidFill>
-                  <a:srgbClr val="132338"/>
-                </a:solidFill>
-                <a:latin typeface="Microsoft JhengHei"/>
-              </a:rPr>
-              <a:t>5</a:t>
-            </a:r>
-          </a:p>
-        </p:txBody>
-      </p:sp>
-      <p:sp>
-        <p:nvSpPr>
-          <p:cNvPr id="39" name="Rectangle 38"/>
-          <p:cNvSpPr/>
-          <p:nvPr/>
-        </p:nvSpPr>
-        <p:spPr>
-          <a:xfrm>
-            <a:off x="877824" y="4636008"/>
-            <a:ext cx="2240280" cy="146304"/>
-          </a:xfrm>
-          <a:prstGeom prst="rect">
-            <a:avLst/>
-          </a:prstGeom>
-          <a:solidFill>
-            <a:srgbClr val="E2E7E6"/>
-          </a:solidFill>
-          <a:ln>
-            <a:solidFill>
-              <a:srgbClr val="E2E7E6"/>
-            </a:solidFill>
-          </a:ln>
-        </p:spPr>
-        <p:style>
-          <a:lnRef idx="1">
-            <a:schemeClr val="accent1"/>
-          </a:lnRef>
-          <a:fillRef idx="3">
-            <a:schemeClr val="accent1"/>
-          </a:fillRef>
-          <a:effectRef idx="2">
-            <a:schemeClr val="accent1"/>
-          </a:effectRef>
-          <a:fontRef idx="minor">
-            <a:schemeClr val="lt1"/>
-          </a:fontRef>
-        </p:style>
-        <p:txBody>
-          <a:bodyPr rtlCol="0" anchor="ctr"/>
-          <a:lstStyle/>
-          <a:p>
-            <a:pPr algn="ctr"/>
-            <a:endParaRPr/>
-          </a:p>
-        </p:txBody>
-      </p:sp>
-      <p:sp>
-        <p:nvSpPr>
-          <p:cNvPr id="40" name="Rectangle 39"/>
-          <p:cNvSpPr/>
-          <p:nvPr/>
-        </p:nvSpPr>
-        <p:spPr>
-          <a:xfrm>
-            <a:off x="877824" y="4636008"/>
-            <a:ext cx="1061185" cy="146304"/>
-          </a:xfrm>
-          <a:prstGeom prst="rect">
-            <a:avLst/>
-          </a:prstGeom>
-          <a:solidFill>
-            <a:srgbClr val="DA9335"/>
-          </a:solidFill>
-          <a:ln>
-            <a:solidFill>
-              <a:srgbClr val="DA9335"/>
-            </a:solidFill>
-          </a:ln>
-        </p:spPr>
-        <p:style>
-          <a:lnRef idx="1">
-            <a:schemeClr val="accent1"/>
-          </a:lnRef>
-          <a:fillRef idx="3">
-            <a:schemeClr val="accent1"/>
-          </a:fillRef>
-          <a:effectRef idx="2">
-            <a:schemeClr val="accent1"/>
-          </a:effectRef>
-          <a:fontRef idx="minor">
-            <a:schemeClr val="lt1"/>
-          </a:fontRef>
-        </p:style>
-        <p:txBody>
-          <a:bodyPr rtlCol="0" anchor="ctr"/>
-          <a:lstStyle/>
-          <a:p>
-            <a:pPr algn="ctr"/>
-            <a:endParaRPr/>
-          </a:p>
-        </p:txBody>
-      </p:sp>
-      <p:sp>
-        <p:nvSpPr>
-          <p:cNvPr id="41" name="TextBox 40"/>
-          <p:cNvSpPr txBox="1"/>
-          <p:nvPr/>
-        </p:nvSpPr>
-        <p:spPr>
-          <a:xfrm>
-            <a:off x="3227832" y="4608576"/>
-            <a:ext cx="1417320" cy="219456"/>
-          </a:xfrm>
-          <a:prstGeom prst="rect">
-            <a:avLst/>
-          </a:prstGeom>
-          <a:noFill/>
-        </p:spPr>
-        <p:txBody>
-          <a:bodyPr wrap="none" lIns="0" tIns="0" rIns="0" bIns="0" anchor="ctr">
-            <a:spAutoFit/>
-          </a:bodyPr>
-          <a:lstStyle/>
-          <a:p>
-            <a:pPr algn="l"/>
-            <a:r>
-              <a:rPr sz="850" b="0">
-                <a:solidFill>
-                  <a:srgbClr val="222B36"/>
-                </a:solidFill>
-                <a:latin typeface="Microsoft JhengHei"/>
-              </a:rPr>
-              <a:t>47.4%  (19)</a:t>
-            </a:r>
-          </a:p>
-        </p:txBody>
-      </p:sp>
-      <p:sp>
-        <p:nvSpPr>
-          <p:cNvPr id="42" name="TextBox 41"/>
-          <p:cNvSpPr txBox="1"/>
-          <p:nvPr/>
-        </p:nvSpPr>
-        <p:spPr>
-          <a:xfrm>
-            <a:off x="530352" y="4974336"/>
-            <a:ext cx="292608" cy="201168"/>
-          </a:xfrm>
-          <a:prstGeom prst="rect">
-            <a:avLst/>
-          </a:prstGeom>
-          <a:noFill/>
-        </p:spPr>
-        <p:txBody>
-          <a:bodyPr wrap="none" lIns="0" tIns="0" rIns="0" bIns="0" anchor="ctr">
-            <a:spAutoFit/>
-          </a:bodyPr>
-          <a:lstStyle/>
-          <a:p>
-            <a:pPr algn="l"/>
-            <a:r>
-              <a:rPr sz="950" b="1">
-                <a:solidFill>
-                  <a:srgbClr val="132338"/>
-                </a:solidFill>
-                <a:latin typeface="Microsoft JhengHei"/>
-              </a:rPr>
-              <a:t>6</a:t>
-            </a:r>
-          </a:p>
-        </p:txBody>
-      </p:sp>
-      <p:sp>
-        <p:nvSpPr>
-          <p:cNvPr id="43" name="Rectangle 42"/>
-          <p:cNvSpPr/>
-          <p:nvPr/>
-        </p:nvSpPr>
-        <p:spPr>
-          <a:xfrm>
-            <a:off x="877824" y="4992623"/>
-            <a:ext cx="2240280" cy="146304"/>
-          </a:xfrm>
-          <a:prstGeom prst="rect">
-            <a:avLst/>
-          </a:prstGeom>
-          <a:solidFill>
-            <a:srgbClr val="E2E7E6"/>
-          </a:solidFill>
-          <a:ln>
-            <a:solidFill>
-              <a:srgbClr val="E2E7E6"/>
-            </a:solidFill>
-          </a:ln>
-        </p:spPr>
-        <p:style>
-          <a:lnRef idx="1">
-            <a:schemeClr val="accent1"/>
-          </a:lnRef>
-          <a:fillRef idx="3">
-            <a:schemeClr val="accent1"/>
-          </a:fillRef>
-          <a:effectRef idx="2">
-            <a:schemeClr val="accent1"/>
-          </a:effectRef>
-          <a:fontRef idx="minor">
-            <a:schemeClr val="lt1"/>
-          </a:fontRef>
-        </p:style>
-        <p:txBody>
-          <a:bodyPr rtlCol="0" anchor="ctr"/>
-          <a:lstStyle/>
-          <a:p>
-            <a:pPr algn="ctr"/>
-            <a:endParaRPr/>
-          </a:p>
-        </p:txBody>
-      </p:sp>
-      <p:sp>
-        <p:nvSpPr>
-          <p:cNvPr id="44" name="Rectangle 43"/>
-          <p:cNvSpPr/>
-          <p:nvPr/>
-        </p:nvSpPr>
-        <p:spPr>
-          <a:xfrm>
-            <a:off x="877824" y="4992623"/>
-            <a:ext cx="1120140" cy="146304"/>
-          </a:xfrm>
-          <a:prstGeom prst="rect">
-            <a:avLst/>
-          </a:prstGeom>
-          <a:solidFill>
-            <a:srgbClr val="DA9335"/>
-          </a:solidFill>
-          <a:ln>
-            <a:solidFill>
-              <a:srgbClr val="DA9335"/>
-            </a:solidFill>
-          </a:ln>
-        </p:spPr>
-        <p:style>
-          <a:lnRef idx="1">
-            <a:schemeClr val="accent1"/>
-          </a:lnRef>
-          <a:fillRef idx="3">
-            <a:schemeClr val="accent1"/>
-          </a:fillRef>
-          <a:effectRef idx="2">
-            <a:schemeClr val="accent1"/>
-          </a:effectRef>
-          <a:fontRef idx="minor">
-            <a:schemeClr val="lt1"/>
-          </a:fontRef>
-        </p:style>
-        <p:txBody>
-          <a:bodyPr rtlCol="0" anchor="ctr"/>
-          <a:lstStyle/>
-          <a:p>
-            <a:pPr algn="ctr"/>
-            <a:endParaRPr/>
-          </a:p>
-        </p:txBody>
-      </p:sp>
-      <p:sp>
-        <p:nvSpPr>
-          <p:cNvPr id="45" name="TextBox 44"/>
-          <p:cNvSpPr txBox="1"/>
-          <p:nvPr/>
-        </p:nvSpPr>
-        <p:spPr>
-          <a:xfrm>
-            <a:off x="3227832" y="4965192"/>
-            <a:ext cx="1417320" cy="219456"/>
-          </a:xfrm>
-          <a:prstGeom prst="rect">
-            <a:avLst/>
-          </a:prstGeom>
-          <a:noFill/>
-        </p:spPr>
-        <p:txBody>
-          <a:bodyPr wrap="none" lIns="0" tIns="0" rIns="0" bIns="0" anchor="ctr">
-            <a:spAutoFit/>
-          </a:bodyPr>
-          <a:lstStyle/>
-          <a:p>
-            <a:pPr algn="l"/>
-            <a:r>
-              <a:rPr sz="850" b="0">
-                <a:solidFill>
-                  <a:srgbClr val="222B36"/>
-                </a:solidFill>
-                <a:latin typeface="Microsoft JhengHei"/>
-              </a:rPr>
-              <a:t>50.0%  (4)</a:t>
-            </a:r>
-          </a:p>
-        </p:txBody>
-      </p:sp>
-      <p:sp>
-        <p:nvSpPr>
-          <p:cNvPr id="46" name="TextBox 45"/>
-          <p:cNvSpPr txBox="1"/>
-          <p:nvPr/>
-        </p:nvSpPr>
-        <p:spPr>
-          <a:xfrm>
-            <a:off x="530352" y="5330952"/>
-            <a:ext cx="292608" cy="201168"/>
-          </a:xfrm>
-          <a:prstGeom prst="rect">
-            <a:avLst/>
-          </a:prstGeom>
-          <a:noFill/>
-        </p:spPr>
-        <p:txBody>
-          <a:bodyPr wrap="none" lIns="0" tIns="0" rIns="0" bIns="0" anchor="ctr">
-            <a:spAutoFit/>
-          </a:bodyPr>
-          <a:lstStyle/>
-          <a:p>
-            <a:pPr algn="l"/>
-            <a:r>
-              <a:rPr sz="950" b="1">
-                <a:solidFill>
-                  <a:srgbClr val="132338"/>
-                </a:solidFill>
-                <a:latin typeface="Microsoft JhengHei"/>
-              </a:rPr>
-              <a:t>7</a:t>
-            </a:r>
-          </a:p>
-        </p:txBody>
-      </p:sp>
-      <p:sp>
-        <p:nvSpPr>
-          <p:cNvPr id="47" name="Rectangle 46"/>
-          <p:cNvSpPr/>
-          <p:nvPr/>
-        </p:nvSpPr>
-        <p:spPr>
-          <a:xfrm>
-            <a:off x="877824" y="5349240"/>
-            <a:ext cx="2240280" cy="146304"/>
-          </a:xfrm>
-          <a:prstGeom prst="rect">
-            <a:avLst/>
-          </a:prstGeom>
-          <a:solidFill>
-            <a:srgbClr val="E2E7E6"/>
-          </a:solidFill>
-          <a:ln>
-            <a:solidFill>
-              <a:srgbClr val="E2E7E6"/>
-            </a:solidFill>
-          </a:ln>
-        </p:spPr>
-        <p:style>
-          <a:lnRef idx="1">
-            <a:schemeClr val="accent1"/>
-          </a:lnRef>
-          <a:fillRef idx="3">
-            <a:schemeClr val="accent1"/>
-          </a:fillRef>
-          <a:effectRef idx="2">
-            <a:schemeClr val="accent1"/>
-          </a:effectRef>
-          <a:fontRef idx="minor">
-            <a:schemeClr val="lt1"/>
-          </a:fontRef>
-        </p:style>
-        <p:txBody>
-          <a:bodyPr rtlCol="0" anchor="ctr"/>
-          <a:lstStyle/>
-          <a:p>
-            <a:pPr algn="ctr"/>
-            <a:endParaRPr/>
-          </a:p>
-        </p:txBody>
-      </p:sp>
-      <p:sp>
-        <p:nvSpPr>
-          <p:cNvPr id="48" name="TextBox 47"/>
-          <p:cNvSpPr txBox="1"/>
-          <p:nvPr/>
-        </p:nvSpPr>
-        <p:spPr>
-          <a:xfrm>
-            <a:off x="3227832" y="5321808"/>
-            <a:ext cx="1417320" cy="219456"/>
-          </a:xfrm>
-          <a:prstGeom prst="rect">
-            <a:avLst/>
-          </a:prstGeom>
-          <a:noFill/>
-        </p:spPr>
-        <p:txBody>
-          <a:bodyPr wrap="none" lIns="0" tIns="0" rIns="0" bIns="0" anchor="ctr">
-            <a:spAutoFit/>
-          </a:bodyPr>
-          <a:lstStyle/>
-          <a:p>
-            <a:pPr algn="l"/>
-            <a:r>
-              <a:rPr sz="850" b="0">
-                <a:solidFill>
-                  <a:srgbClr val="222B36"/>
-                </a:solidFill>
-                <a:latin typeface="Microsoft JhengHei"/>
-              </a:rPr>
-              <a:t>N/A  (0)</a:t>
-            </a:r>
-          </a:p>
-        </p:txBody>
-      </p:sp>
-      <p:sp>
-        <p:nvSpPr>
-          <p:cNvPr id="49" name="TextBox 48"/>
-          <p:cNvSpPr txBox="1"/>
-          <p:nvPr/>
-        </p:nvSpPr>
-        <p:spPr>
-          <a:xfrm>
-            <a:off x="521207" y="5788152"/>
-            <a:ext cx="4526280" cy="201168"/>
-          </a:xfrm>
-          <a:prstGeom prst="rect">
-            <a:avLst/>
-          </a:prstGeom>
-          <a:noFill/>
-        </p:spPr>
-        <p:txBody>
-          <a:bodyPr wrap="none" lIns="0" tIns="0" rIns="0" bIns="0" anchor="ctr">
-            <a:spAutoFit/>
-          </a:bodyPr>
-          <a:lstStyle/>
-          <a:p>
-            <a:pPr algn="l"/>
-            <a:r>
-              <a:rPr sz="850" b="0">
-                <a:solidFill>
-                  <a:srgbClr val="667280"/>
-                </a:solidFill>
-                <a:latin typeface="Microsoft JhengHei"/>
-              </a:rPr>
-              <a:t>模型設定：max_depth=12 · min_samples_leaf=1</a:t>
-            </a:r>
-          </a:p>
-        </p:txBody>
-      </p:sp>
-      <p:sp>
-        <p:nvSpPr>
-          <p:cNvPr id="50" name="Rounded Rectangle 49"/>
-          <p:cNvSpPr/>
-          <p:nvPr/>
-        </p:nvSpPr>
-        <p:spPr>
-          <a:xfrm>
-            <a:off x="5230368" y="1234440"/>
-            <a:ext cx="6455664" cy="4754880"/>
-          </a:xfrm>
-          <a:prstGeom prst="roundRect">
-            <a:avLst/>
-          </a:prstGeom>
-          <a:solidFill>
-            <a:srgbClr val="FFFFFF"/>
-          </a:solidFill>
-          <a:ln>
-            <a:solidFill>
-              <a:srgbClr val="E2E7E6"/>
-            </a:solidFill>
-          </a:ln>
-        </p:spPr>
-        <p:style>
-          <a:lnRef idx="1">
-            <a:schemeClr val="accent1"/>
-          </a:lnRef>
-          <a:fillRef idx="3">
-            <a:schemeClr val="accent1"/>
-          </a:fillRef>
-          <a:effectRef idx="2">
-            <a:schemeClr val="accent1"/>
-          </a:effectRef>
-          <a:fontRef idx="minor">
-            <a:schemeClr val="lt1"/>
-          </a:fontRef>
-        </p:style>
-        <p:txBody>
-          <a:bodyPr rtlCol="0" anchor="ctr"/>
-          <a:lstStyle/>
-          <a:p>
-            <a:pPr algn="ctr"/>
-            <a:endParaRPr/>
-          </a:p>
-        </p:txBody>
-      </p:sp>
-      <p:sp>
-        <p:nvSpPr>
-          <p:cNvPr id="51" name="TextBox 50"/>
-          <p:cNvSpPr txBox="1"/>
-          <p:nvPr/>
-        </p:nvSpPr>
-        <p:spPr>
-          <a:xfrm>
-            <a:off x="5468112" y="1417320"/>
-            <a:ext cx="3657600" cy="246888"/>
-          </a:xfrm>
-          <a:prstGeom prst="rect">
-            <a:avLst/>
-          </a:prstGeom>
-          <a:noFill/>
-        </p:spPr>
-        <p:txBody>
-          <a:bodyPr wrap="none" lIns="0" tIns="0" rIns="0" bIns="0" anchor="ctr">
-            <a:spAutoFit/>
-          </a:bodyPr>
-          <a:lstStyle/>
-          <a:p>
-            <a:pPr algn="l"/>
-            <a:r>
-              <a:rPr sz="1300" b="1">
-                <a:solidFill>
-                  <a:srgbClr val="132338"/>
-                </a:solidFill>
-                <a:latin typeface="Microsoft JhengHei"/>
-              </a:rPr>
-              <a:t>混淆矩陣</a:t>
-            </a:r>
-          </a:p>
-        </p:txBody>
-      </p:sp>
-      <p:sp>
-        <p:nvSpPr>
-          <p:cNvPr id="52" name="TextBox 51"/>
-          <p:cNvSpPr txBox="1"/>
-          <p:nvPr/>
-        </p:nvSpPr>
-        <p:spPr>
-          <a:xfrm>
-            <a:off x="8942832" y="1444752"/>
-            <a:ext cx="2450592" cy="182880"/>
-          </a:xfrm>
-          <a:prstGeom prst="rect">
-            <a:avLst/>
-          </a:prstGeom>
-          <a:noFill/>
-        </p:spPr>
-        <p:txBody>
-          <a:bodyPr wrap="none" lIns="0" tIns="0" rIns="0" bIns="0" anchor="ctr">
-            <a:spAutoFit/>
-          </a:bodyPr>
-          <a:lstStyle/>
-          <a:p>
-            <a:pPr algn="r"/>
-            <a:r>
-              <a:rPr sz="850" b="0">
-                <a:solidFill>
-                  <a:srgbClr val="667280"/>
-                </a:solidFill>
-                <a:latin typeface="Microsoft JhengHei"/>
-              </a:rPr>
-              <a:t>列＝實際｜欄＝預測</a:t>
-            </a:r>
-          </a:p>
-        </p:txBody>
-      </p:sp>
-      <p:pic>
-        <p:nvPicPr>
-          <p:cNvPr id="53" name="Picture 52" descr="decision_tree_confusion_matrix.png"/>
-          <p:cNvPicPr>
-            <a:picLocks noChangeAspect="1"/>
-          </p:cNvPicPr>
-          <p:nvPr/>
-        </p:nvPicPr>
-        <p:blipFill>
-          <a:blip r:embed="rId2"/>
-          <a:stretch>
-            <a:fillRect/>
-          </a:stretch>
-        </p:blipFill>
-        <p:spPr>
-          <a:xfrm>
-            <a:off x="5614416" y="1737360"/>
-            <a:ext cx="5650992" cy="3968496"/>
-          </a:xfrm>
-          <a:prstGeom prst="rect">
-            <a:avLst/>
-          </a:prstGeom>
-        </p:spPr>
-      </p:pic>
-      <p:sp>
-        <p:nvSpPr>
-          <p:cNvPr id="54" name="Rounded Rectangle 53"/>
-          <p:cNvSpPr/>
-          <p:nvPr/>
-        </p:nvSpPr>
-        <p:spPr>
-          <a:xfrm>
-            <a:off x="502920" y="6126480"/>
-            <a:ext cx="11183112" cy="438912"/>
-          </a:xfrm>
-          <a:prstGeom prst="roundRect">
-            <a:avLst/>
-          </a:prstGeom>
-          <a:solidFill>
-            <a:srgbClr val="132338"/>
-          </a:solidFill>
-          <a:ln>
-            <a:solidFill>
-              <a:srgbClr val="132338"/>
-            </a:solidFill>
-          </a:ln>
-        </p:spPr>
-        <p:style>
-          <a:lnRef idx="1">
-            <a:schemeClr val="accent1"/>
-          </a:lnRef>
-          <a:fillRef idx="3">
-            <a:schemeClr val="accent1"/>
-          </a:fillRef>
-          <a:effectRef idx="2">
-            <a:schemeClr val="accent1"/>
-          </a:effectRef>
-          <a:fontRef idx="minor">
-            <a:schemeClr val="lt1"/>
-          </a:fontRef>
-        </p:style>
-        <p:txBody>
-          <a:bodyPr rtlCol="0" anchor="ctr"/>
-          <a:lstStyle/>
-          <a:p>
-            <a:pPr algn="ctr"/>
-            <a:endParaRPr/>
-          </a:p>
-        </p:txBody>
-      </p:sp>
-      <p:sp>
-        <p:nvSpPr>
-          <p:cNvPr id="55" name="TextBox 54"/>
-          <p:cNvSpPr txBox="1"/>
-          <p:nvPr/>
-        </p:nvSpPr>
-        <p:spPr>
-          <a:xfrm>
-            <a:off x="713232" y="6263695"/>
-            <a:ext cx="6585136" cy="146194"/>
-          </a:xfrm>
-          <a:prstGeom prst="rect">
-            <a:avLst/>
-          </a:prstGeom>
-          <a:noFill/>
-        </p:spPr>
-        <p:txBody>
-          <a:bodyPr wrap="none" lIns="0" tIns="0" rIns="0" bIns="0" anchor="ctr">
-            <a:spAutoFit/>
-          </a:bodyPr>
-          <a:lstStyle/>
-          <a:p>
-            <a:pPr algn="l"/>
-            <a:r>
-              <a:rPr sz="950" b="1" dirty="0" err="1">
-                <a:solidFill>
-                  <a:schemeClr val="bg1"/>
-                </a:solidFill>
-                <a:latin typeface="Microsoft JhengHei"/>
-              </a:rPr>
-              <a:t>結論｜目前為基準模型：整體辨識能力有限；震度</a:t>
-            </a:r>
-            <a:r>
-              <a:rPr sz="950" b="1" dirty="0">
-                <a:solidFill>
-                  <a:schemeClr val="bg1"/>
-                </a:solidFill>
-                <a:latin typeface="Microsoft JhengHei"/>
-              </a:rPr>
-              <a:t> 5、6 </a:t>
-            </a:r>
-            <a:r>
-              <a:rPr sz="950" b="1" dirty="0" err="1">
-                <a:solidFill>
-                  <a:schemeClr val="bg1"/>
-                </a:solidFill>
-                <a:latin typeface="Microsoft JhengHei"/>
-              </a:rPr>
-              <a:t>樣本僅</a:t>
-            </a:r>
-            <a:r>
-              <a:rPr sz="950" b="1" dirty="0">
-                <a:solidFill>
-                  <a:schemeClr val="bg1"/>
-                </a:solidFill>
-                <a:latin typeface="Microsoft JhengHei"/>
-              </a:rPr>
-              <a:t> 19、4 </a:t>
-            </a:r>
-            <a:r>
-              <a:rPr sz="950" b="1" dirty="0" err="1">
-                <a:solidFill>
-                  <a:schemeClr val="bg1"/>
-                </a:solidFill>
-                <a:latin typeface="Microsoft JhengHei"/>
-              </a:rPr>
-              <a:t>筆，震度</a:t>
-            </a:r>
-            <a:r>
-              <a:rPr sz="950" b="1" dirty="0">
-                <a:solidFill>
-                  <a:schemeClr val="bg1"/>
-                </a:solidFill>
-                <a:latin typeface="Microsoft JhengHei"/>
-              </a:rPr>
-              <a:t> 7 </a:t>
-            </a:r>
-            <a:r>
-              <a:rPr sz="950" b="1" dirty="0" err="1">
-                <a:solidFill>
-                  <a:schemeClr val="bg1"/>
-                </a:solidFill>
-                <a:latin typeface="Microsoft JhengHei"/>
-              </a:rPr>
-              <a:t>無測試樣本，命中率不宜視為穩定結論</a:t>
-            </a:r>
-            <a:r>
-              <a:rPr sz="950" b="1" dirty="0">
-                <a:solidFill>
-                  <a:schemeClr val="bg1"/>
-                </a:solidFill>
-                <a:latin typeface="Microsoft JhengHei"/>
-              </a:rPr>
-              <a:t>。</a:t>
+              <a:t>判讀原則｜先比較 chronological test Macro Recall，再以 Accuracy 作為次要排序。</a:t>
             </a:r>
           </a:p>
         </p:txBody>

</xml_diff>